<commit_message>
update slides for presentation 20260108
</commit_message>
<xml_diff>
--- a/slides/20260108.pptx
+++ b/slides/20260108.pptx
@@ -5,10 +5,9 @@
     <p:sldMasterId id="2147483648" r:id="rId1"/>
   </p:sldMasterIdLst>
   <p:sldIdLst>
-    <p:sldId id="265" r:id="rId2"/>
+    <p:sldId id="268" r:id="rId2"/>
     <p:sldId id="266" r:id="rId3"/>
-    <p:sldId id="264" r:id="rId4"/>
-    <p:sldId id="263" r:id="rId5"/>
+    <p:sldId id="267" r:id="rId4"/>
   </p:sldIdLst>
   <p:sldSz cx="12192000" cy="6858000"/>
   <p:notesSz cx="6858000" cy="9144000"/>
@@ -262,7 +261,7 @@
           <a:p>
             <a:fld id="{3F567BA6-CBC2-4FF0-810E-3ED1BF2C4381}" type="datetimeFigureOut">
               <a:rPr lang="zh-CN" altLang="en-US" smtClean="0"/>
-              <a:t>2025/12/18</a:t>
+              <a:t>2026/1/8</a:t>
             </a:fld>
             <a:endParaRPr lang="zh-CN" altLang="en-US"/>
           </a:p>
@@ -460,7 +459,7 @@
           <a:p>
             <a:fld id="{3F567BA6-CBC2-4FF0-810E-3ED1BF2C4381}" type="datetimeFigureOut">
               <a:rPr lang="zh-CN" altLang="en-US" smtClean="0"/>
-              <a:t>2025/12/18</a:t>
+              <a:t>2026/1/8</a:t>
             </a:fld>
             <a:endParaRPr lang="zh-CN" altLang="en-US"/>
           </a:p>
@@ -668,7 +667,7 @@
           <a:p>
             <a:fld id="{3F567BA6-CBC2-4FF0-810E-3ED1BF2C4381}" type="datetimeFigureOut">
               <a:rPr lang="zh-CN" altLang="en-US" smtClean="0"/>
-              <a:t>2025/12/18</a:t>
+              <a:t>2026/1/8</a:t>
             </a:fld>
             <a:endParaRPr lang="zh-CN" altLang="en-US"/>
           </a:p>
@@ -866,7 +865,7 @@
           <a:p>
             <a:fld id="{3F567BA6-CBC2-4FF0-810E-3ED1BF2C4381}" type="datetimeFigureOut">
               <a:rPr lang="zh-CN" altLang="en-US" smtClean="0"/>
-              <a:t>2025/12/18</a:t>
+              <a:t>2026/1/8</a:t>
             </a:fld>
             <a:endParaRPr lang="zh-CN" altLang="en-US"/>
           </a:p>
@@ -1141,7 +1140,7 @@
           <a:p>
             <a:fld id="{3F567BA6-CBC2-4FF0-810E-3ED1BF2C4381}" type="datetimeFigureOut">
               <a:rPr lang="zh-CN" altLang="en-US" smtClean="0"/>
-              <a:t>2025/12/18</a:t>
+              <a:t>2026/1/8</a:t>
             </a:fld>
             <a:endParaRPr lang="zh-CN" altLang="en-US"/>
           </a:p>
@@ -1406,7 +1405,7 @@
           <a:p>
             <a:fld id="{3F567BA6-CBC2-4FF0-810E-3ED1BF2C4381}" type="datetimeFigureOut">
               <a:rPr lang="zh-CN" altLang="en-US" smtClean="0"/>
-              <a:t>2025/12/18</a:t>
+              <a:t>2026/1/8</a:t>
             </a:fld>
             <a:endParaRPr lang="zh-CN" altLang="en-US"/>
           </a:p>
@@ -1818,7 +1817,7 @@
           <a:p>
             <a:fld id="{3F567BA6-CBC2-4FF0-810E-3ED1BF2C4381}" type="datetimeFigureOut">
               <a:rPr lang="zh-CN" altLang="en-US" smtClean="0"/>
-              <a:t>2025/12/18</a:t>
+              <a:t>2026/1/8</a:t>
             </a:fld>
             <a:endParaRPr lang="zh-CN" altLang="en-US"/>
           </a:p>
@@ -1959,7 +1958,7 @@
           <a:p>
             <a:fld id="{3F567BA6-CBC2-4FF0-810E-3ED1BF2C4381}" type="datetimeFigureOut">
               <a:rPr lang="zh-CN" altLang="en-US" smtClean="0"/>
-              <a:t>2025/12/18</a:t>
+              <a:t>2026/1/8</a:t>
             </a:fld>
             <a:endParaRPr lang="zh-CN" altLang="en-US"/>
           </a:p>
@@ -2072,7 +2071,7 @@
           <a:p>
             <a:fld id="{3F567BA6-CBC2-4FF0-810E-3ED1BF2C4381}" type="datetimeFigureOut">
               <a:rPr lang="zh-CN" altLang="en-US" smtClean="0"/>
-              <a:t>2025/12/18</a:t>
+              <a:t>2026/1/8</a:t>
             </a:fld>
             <a:endParaRPr lang="zh-CN" altLang="en-US"/>
           </a:p>
@@ -2383,7 +2382,7 @@
           <a:p>
             <a:fld id="{3F567BA6-CBC2-4FF0-810E-3ED1BF2C4381}" type="datetimeFigureOut">
               <a:rPr lang="zh-CN" altLang="en-US" smtClean="0"/>
-              <a:t>2025/12/18</a:t>
+              <a:t>2026/1/8</a:t>
             </a:fld>
             <a:endParaRPr lang="zh-CN" altLang="en-US"/>
           </a:p>
@@ -2671,7 +2670,7 @@
           <a:p>
             <a:fld id="{3F567BA6-CBC2-4FF0-810E-3ED1BF2C4381}" type="datetimeFigureOut">
               <a:rPr lang="zh-CN" altLang="en-US" smtClean="0"/>
-              <a:t>2025/12/18</a:t>
+              <a:t>2026/1/8</a:t>
             </a:fld>
             <a:endParaRPr lang="zh-CN" altLang="en-US"/>
           </a:p>
@@ -2912,7 +2911,7 @@
           <a:p>
             <a:fld id="{3F567BA6-CBC2-4FF0-810E-3ED1BF2C4381}" type="datetimeFigureOut">
               <a:rPr lang="zh-CN" altLang="en-US" smtClean="0"/>
-              <a:t>2025/12/18</a:t>
+              <a:t>2026/1/8</a:t>
             </a:fld>
             <a:endParaRPr lang="zh-CN" altLang="en-US"/>
           </a:p>
@@ -3329,153 +3328,70 @@
           <a:chExt cx="0" cy="0"/>
         </a:xfrm>
       </p:grpSpPr>
-      <p:sp>
-        <p:nvSpPr>
-          <p:cNvPr id="4" name="文本框 3">
-            <a:extLst>
-              <a:ext uri="{FF2B5EF4-FFF2-40B4-BE49-F238E27FC236}">
-                <a16:creationId xmlns:a16="http://schemas.microsoft.com/office/drawing/2014/main" id="{A898100F-D511-C3F5-4EF0-57F49F02315C}"/>
-              </a:ext>
-            </a:extLst>
-          </p:cNvPr>
-          <p:cNvSpPr txBox="1"/>
+      <p:pic>
+        <p:nvPicPr>
+          <p:cNvPr id="9" name="图片 8" descr="图表, 条形图&#10;&#10;AI 生成的内容可能不正确。">
+            <a:extLst>
+              <a:ext uri="{FF2B5EF4-FFF2-40B4-BE49-F238E27FC236}">
+                <a16:creationId xmlns:a16="http://schemas.microsoft.com/office/drawing/2014/main" id="{AAEEFAF9-0692-5317-7DBF-7438FE01AF4E}"/>
+              </a:ext>
+            </a:extLst>
+          </p:cNvPr>
+          <p:cNvPicPr>
+            <a:picLocks noChangeAspect="1"/>
+          </p:cNvPicPr>
           <p:nvPr/>
-        </p:nvSpPr>
+        </p:nvPicPr>
+        <p:blipFill>
+          <a:blip r:embed="rId2"/>
+          <a:stretch>
+            <a:fillRect/>
+          </a:stretch>
+        </p:blipFill>
         <p:spPr>
           <a:xfrm>
-            <a:off x="479719" y="151179"/>
-            <a:ext cx="11219222" cy="4278094"/>
+            <a:off x="876532" y="834390"/>
+            <a:ext cx="4785360" cy="5189220"/>
           </a:xfrm>
           <a:prstGeom prst="rect">
             <a:avLst/>
           </a:prstGeom>
-          <a:noFill/>
         </p:spPr>
-        <p:txBody>
-          <a:bodyPr wrap="square" rtlCol="0">
-            <a:spAutoFit/>
-          </a:bodyPr>
-          <a:lstStyle/>
-          <a:p>
-            <a:r>
-              <a:rPr lang="en-US" altLang="zh-CN" sz="3200" dirty="0">
-                <a:latin typeface="Arial" panose="020B0604020202020204" pitchFamily="34" charset="0"/>
-                <a:cs typeface="Arial" panose="020B0604020202020204" pitchFamily="34" charset="0"/>
-              </a:rPr>
-              <a:t>Verbalized Sampling:</a:t>
-            </a:r>
-          </a:p>
-          <a:p>
-            <a:endParaRPr lang="en-US" altLang="zh-CN" sz="2000" dirty="0">
-              <a:latin typeface="Arial" panose="020B0604020202020204" pitchFamily="34" charset="0"/>
-              <a:cs typeface="Arial" panose="020B0604020202020204" pitchFamily="34" charset="0"/>
-            </a:endParaRPr>
-          </a:p>
-          <a:p>
-            <a:r>
-              <a:rPr lang="en-US" altLang="zh-CN" sz="2000" dirty="0">
-                <a:solidFill>
-                  <a:srgbClr val="FF0000"/>
-                </a:solidFill>
-                <a:latin typeface="Arial" panose="020B0604020202020204" pitchFamily="34" charset="0"/>
-                <a:cs typeface="Arial" panose="020B0604020202020204" pitchFamily="34" charset="0"/>
-              </a:rPr>
-              <a:t>System prompt</a:t>
-            </a:r>
-            <a:r>
-              <a:rPr lang="en-US" altLang="zh-CN" sz="2000" dirty="0">
-                <a:latin typeface="Arial" panose="020B0604020202020204" pitchFamily="34" charset="0"/>
-                <a:cs typeface="Arial" panose="020B0604020202020204" pitchFamily="34" charset="0"/>
-              </a:rPr>
-              <a:t>: You are a helpful assistant. For each query, please generate a set of five possible responses, each within a separate &lt;response&gt; tag. Responses should each include a &lt;text&gt; and a numeric &lt;probability&gt;. Please sample at random from the [full distribution / tails of the distribution, such that the probability of each response is less than 0.10].</a:t>
-            </a:r>
-          </a:p>
-          <a:p>
-            <a:r>
-              <a:rPr lang="en-US" altLang="zh-CN" sz="2000" dirty="0">
-                <a:solidFill>
-                  <a:srgbClr val="FF0000"/>
-                </a:solidFill>
-                <a:latin typeface="Arial" panose="020B0604020202020204" pitchFamily="34" charset="0"/>
-                <a:cs typeface="Arial" panose="020B0604020202020204" pitchFamily="34" charset="0"/>
-              </a:rPr>
-              <a:t>User prompt</a:t>
-            </a:r>
-            <a:r>
-              <a:rPr lang="en-US" altLang="zh-CN" sz="2000" dirty="0">
-                <a:latin typeface="Arial" panose="020B0604020202020204" pitchFamily="34" charset="0"/>
-                <a:cs typeface="Arial" panose="020B0604020202020204" pitchFamily="34" charset="0"/>
-              </a:rPr>
-              <a:t>: …</a:t>
-            </a:r>
-          </a:p>
-          <a:p>
-            <a:endParaRPr lang="en-US" altLang="zh-CN" sz="2000" dirty="0">
-              <a:latin typeface="Arial" panose="020B0604020202020204" pitchFamily="34" charset="0"/>
-              <a:cs typeface="Arial" panose="020B0604020202020204" pitchFamily="34" charset="0"/>
-            </a:endParaRPr>
-          </a:p>
-          <a:p>
-            <a:r>
-              <a:rPr lang="en-US" altLang="zh-CN" sz="2000" dirty="0">
-                <a:solidFill>
-                  <a:srgbClr val="FF0000"/>
-                </a:solidFill>
-                <a:latin typeface="Arial" panose="020B0604020202020204" pitchFamily="34" charset="0"/>
-                <a:cs typeface="Arial" panose="020B0604020202020204" pitchFamily="34" charset="0"/>
-              </a:rPr>
-              <a:t>Output</a:t>
-            </a:r>
-            <a:r>
-              <a:rPr lang="en-US" altLang="zh-CN" sz="2000" dirty="0">
-                <a:latin typeface="Arial" panose="020B0604020202020204" pitchFamily="34" charset="0"/>
-                <a:cs typeface="Arial" panose="020B0604020202020204" pitchFamily="34" charset="0"/>
-              </a:rPr>
-              <a:t>:</a:t>
-            </a:r>
-          </a:p>
-          <a:p>
-            <a:r>
-              <a:rPr lang="en-US" altLang="zh-CN" sz="2000" dirty="0">
-                <a:latin typeface="Arial" panose="020B0604020202020204" pitchFamily="34" charset="0"/>
-                <a:cs typeface="Arial" panose="020B0604020202020204" pitchFamily="34" charset="0"/>
-              </a:rPr>
-              <a:t>&lt;response&gt;</a:t>
-            </a:r>
-          </a:p>
-          <a:p>
-            <a:r>
-              <a:rPr lang="en-US" altLang="zh-CN" sz="2000" dirty="0">
-                <a:latin typeface="Arial" panose="020B0604020202020204" pitchFamily="34" charset="0"/>
-                <a:cs typeface="Arial" panose="020B0604020202020204" pitchFamily="34" charset="0"/>
-              </a:rPr>
-              <a:t>&lt;text&gt;context&lt;/text&gt;</a:t>
-            </a:r>
-          </a:p>
-          <a:p>
-            <a:r>
-              <a:rPr lang="en-US" altLang="zh-CN" sz="2000" dirty="0">
-                <a:latin typeface="Arial" panose="020B0604020202020204" pitchFamily="34" charset="0"/>
-                <a:cs typeface="Arial" panose="020B0604020202020204" pitchFamily="34" charset="0"/>
-              </a:rPr>
-              <a:t>&lt;probability&gt;X&lt;/probability&gt;	X=The probability that the LLM will output this context</a:t>
-            </a:r>
-          </a:p>
-          <a:p>
-            <a:r>
-              <a:rPr lang="en-US" altLang="zh-CN" sz="2000" dirty="0">
-                <a:latin typeface="Arial" panose="020B0604020202020204" pitchFamily="34" charset="0"/>
-                <a:cs typeface="Arial" panose="020B0604020202020204" pitchFamily="34" charset="0"/>
-              </a:rPr>
-              <a:t>…</a:t>
-            </a:r>
-          </a:p>
-        </p:txBody>
-      </p:sp>
+      </p:pic>
+      <p:pic>
+        <p:nvPicPr>
+          <p:cNvPr id="13" name="图片 12" descr="图表, 条形图&#10;&#10;AI 生成的内容可能不正确。">
+            <a:extLst>
+              <a:ext uri="{FF2B5EF4-FFF2-40B4-BE49-F238E27FC236}">
+                <a16:creationId xmlns:a16="http://schemas.microsoft.com/office/drawing/2014/main" id="{A6A6B390-9DAC-F280-2A71-6928DD5A1128}"/>
+              </a:ext>
+            </a:extLst>
+          </p:cNvPr>
+          <p:cNvPicPr>
+            <a:picLocks noChangeAspect="1"/>
+          </p:cNvPicPr>
+          <p:nvPr/>
+        </p:nvPicPr>
+        <p:blipFill>
+          <a:blip r:embed="rId3"/>
+          <a:stretch>
+            <a:fillRect/>
+          </a:stretch>
+        </p:blipFill>
+        <p:spPr>
+          <a:xfrm>
+            <a:off x="6530109" y="834390"/>
+            <a:ext cx="4785360" cy="5189220"/>
+          </a:xfrm>
+          <a:prstGeom prst="rect">
+            <a:avLst/>
+          </a:prstGeom>
+        </p:spPr>
+      </p:pic>
     </p:spTree>
     <p:extLst>
       <p:ext uri="{BB962C8B-B14F-4D97-AF65-F5344CB8AC3E}">
-        <p14:creationId xmlns:p14="http://schemas.microsoft.com/office/powerpoint/2010/main" val="3320490622"/>
+        <p14:creationId xmlns:p14="http://schemas.microsoft.com/office/powerpoint/2010/main" val="3938257449"/>
       </p:ext>
     </p:extLst>
   </p:cSld>
@@ -3517,7 +3433,7 @@
         <p:spPr>
           <a:xfrm>
             <a:off x="479719" y="151179"/>
-            <a:ext cx="11219222" cy="4955203"/>
+            <a:ext cx="11219222" cy="4216539"/>
           </a:xfrm>
           <a:prstGeom prst="rect">
             <a:avLst/>
@@ -3535,7 +3451,7 @@
                 <a:latin typeface="Arial" panose="020B0604020202020204" pitchFamily="34" charset="0"/>
                 <a:cs typeface="Arial" panose="020B0604020202020204" pitchFamily="34" charset="0"/>
               </a:rPr>
-              <a:t>Comparison Experiment:</a:t>
+              <a:t>Experiment setup:</a:t>
             </a:r>
           </a:p>
           <a:p>
@@ -3546,14 +3462,11 @@
           </a:p>
           <a:p>
             <a:r>
-              <a:rPr lang="en-US" altLang="zh-CN" sz="2000" dirty="0">
-                <a:solidFill>
-                  <a:srgbClr val="FF0000"/>
-                </a:solidFill>
+              <a:rPr lang="en-US" altLang="zh-CN" sz="2800" dirty="0">
                 <a:latin typeface="Arial" panose="020B0604020202020204" pitchFamily="34" charset="0"/>
                 <a:cs typeface="Arial" panose="020B0604020202020204" pitchFamily="34" charset="0"/>
               </a:rPr>
-              <a:t>Confidence score vs Ranking vs Majority voting</a:t>
+              <a:t>Experiment models:</a:t>
             </a:r>
           </a:p>
           <a:p>
@@ -3567,28 +3480,32 @@
               <a:rPr lang="en-US" altLang="zh-CN" sz="2000" dirty="0">
                 <a:latin typeface="Arial" panose="020B0604020202020204" pitchFamily="34" charset="0"/>
                 <a:cs typeface="Arial" panose="020B0604020202020204" pitchFamily="34" charset="0"/>
-                <a:hlinkClick r:id="rId2"/>
               </a:rPr>
-              <a:t>From Generation to Judgment: Opportunities and Challenges of LLM-as-a-judge</a:t>
-            </a:r>
+              <a:t>open-source model: qwen3</a:t>
+            </a:r>
+          </a:p>
+          <a:p>
+            <a:r>
+              <a:rPr lang="en-US" altLang="zh-CN" sz="2000" dirty="0">
+                <a:latin typeface="Arial" panose="020B0604020202020204" pitchFamily="34" charset="0"/>
+                <a:cs typeface="Arial" panose="020B0604020202020204" pitchFamily="34" charset="0"/>
+              </a:rPr>
+              <a:t>close-source models: gpt-4o, gpt-5, gemini-3-pro-preview-11-2025</a:t>
+            </a:r>
+          </a:p>
+          <a:p>
             <a:endParaRPr lang="en-US" altLang="zh-CN" sz="2000" dirty="0">
               <a:latin typeface="Arial" panose="020B0604020202020204" pitchFamily="34" charset="0"/>
               <a:cs typeface="Arial" panose="020B0604020202020204" pitchFamily="34" charset="0"/>
             </a:endParaRPr>
           </a:p>
           <a:p>
-            <a:endParaRPr lang="en-US" altLang="zh-CN" sz="2000" dirty="0">
-              <a:latin typeface="Arial" panose="020B0604020202020204" pitchFamily="34" charset="0"/>
-              <a:cs typeface="Arial" panose="020B0604020202020204" pitchFamily="34" charset="0"/>
-            </a:endParaRPr>
-          </a:p>
-          <a:p>
-            <a:r>
-              <a:rPr lang="en-US" altLang="zh-CN" sz="3200" dirty="0">
+            <a:r>
+              <a:rPr lang="en-US" altLang="zh-CN" sz="2800" dirty="0">
                 <a:latin typeface="Arial" panose="020B0604020202020204" pitchFamily="34" charset="0"/>
                 <a:cs typeface="Arial" panose="020B0604020202020204" pitchFamily="34" charset="0"/>
               </a:rPr>
-              <a:t>Final Experiment datasets:</a:t>
+              <a:t>Experiment datasets:</a:t>
             </a:r>
           </a:p>
           <a:p>
@@ -3617,7 +3534,7 @@
                 <a:latin typeface="Arial" panose="020B0604020202020204" pitchFamily="34" charset="0"/>
                 <a:cs typeface="Arial" panose="020B0604020202020204" pitchFamily="34" charset="0"/>
               </a:rPr>
-              <a:t>, 400 samples from </a:t>
+              <a:t>, 399 samples from </a:t>
             </a:r>
             <a:r>
               <a:rPr lang="en-US" altLang="zh-CN" sz="2000" dirty="0" err="1">
@@ -3631,7 +3548,7 @@
                 <a:latin typeface="Arial" panose="020B0604020202020204" pitchFamily="34" charset="0"/>
                 <a:cs typeface="Arial" panose="020B0604020202020204" pitchFamily="34" charset="0"/>
               </a:rPr>
-              <a:t>, 1067 samples from </a:t>
+              <a:t>, 610 samples from </a:t>
             </a:r>
             <a:r>
               <a:rPr lang="en-US" altLang="zh-CN" sz="2000" dirty="0" err="1">
@@ -3646,64 +3563,15 @@
             </a:endParaRPr>
           </a:p>
           <a:p>
-            <a:endParaRPr lang="en-US" altLang="zh-CN" sz="2000" dirty="0">
-              <a:latin typeface="Arial" panose="020B0604020202020204" pitchFamily="34" charset="0"/>
-              <a:cs typeface="Arial" panose="020B0604020202020204" pitchFamily="34" charset="0"/>
-            </a:endParaRPr>
-          </a:p>
-          <a:p>
-            <a:r>
-              <a:rPr lang="en-US" altLang="zh-CN" sz="3200" dirty="0">
-                <a:latin typeface="Arial" panose="020B0604020202020204" pitchFamily="34" charset="0"/>
-                <a:cs typeface="Arial" panose="020B0604020202020204" pitchFamily="34" charset="0"/>
-              </a:rPr>
-              <a:t>Final Experiment models:</a:t>
-            </a:r>
-          </a:p>
-          <a:p>
-            <a:endParaRPr lang="en-US" altLang="zh-CN" sz="2000" dirty="0">
-              <a:latin typeface="Arial" panose="020B0604020202020204" pitchFamily="34" charset="0"/>
-              <a:cs typeface="Arial" panose="020B0604020202020204" pitchFamily="34" charset="0"/>
-            </a:endParaRPr>
-          </a:p>
-          <a:p>
             <a:r>
               <a:rPr lang="en-US" altLang="zh-CN" sz="2000" dirty="0">
                 <a:latin typeface="Arial" panose="020B0604020202020204" pitchFamily="34" charset="0"/>
                 <a:cs typeface="Arial" panose="020B0604020202020204" pitchFamily="34" charset="0"/>
               </a:rPr>
-              <a:t>open-source model: gemma-3</a:t>
-            </a:r>
-          </a:p>
-          <a:p>
-            <a:r>
-              <a:rPr lang="en-US" altLang="zh-CN" sz="2000" dirty="0">
-                <a:latin typeface="Arial" panose="020B0604020202020204" pitchFamily="34" charset="0"/>
-                <a:cs typeface="Arial" panose="020B0604020202020204" pitchFamily="34" charset="0"/>
-              </a:rPr>
-              <a:t>close-source models: gpt-4o, gpt-5, </a:t>
-            </a:r>
-            <a:r>
-              <a:rPr lang="en-US" altLang="zh-CN" sz="2000" dirty="0" err="1">
-                <a:latin typeface="Arial" panose="020B0604020202020204" pitchFamily="34" charset="0"/>
-                <a:cs typeface="Arial" panose="020B0604020202020204" pitchFamily="34" charset="0"/>
-              </a:rPr>
-              <a:t>gemini</a:t>
-            </a:r>
-            <a:r>
-              <a:rPr lang="en-US" altLang="zh-CN" sz="2000" dirty="0">
-                <a:latin typeface="Arial" panose="020B0604020202020204" pitchFamily="34" charset="0"/>
-                <a:cs typeface="Arial" panose="020B0604020202020204" pitchFamily="34" charset="0"/>
-              </a:rPr>
-              <a:t>-pro-latest</a:t>
-            </a:r>
-            <a:r>
-              <a:rPr lang="en-US" altLang="zh-CN" sz="2000">
-                <a:latin typeface="Arial" panose="020B0604020202020204" pitchFamily="34" charset="0"/>
-                <a:cs typeface="Arial" panose="020B0604020202020204" pitchFamily="34" charset="0"/>
-              </a:rPr>
-              <a:t>, claude-sonnet-4-5</a:t>
-            </a:r>
+              <a:t>total 1826 samples</a:t>
+            </a:r>
+          </a:p>
+          <a:p>
             <a:endParaRPr lang="en-US" altLang="zh-CN" sz="2000" dirty="0">
               <a:latin typeface="Arial" panose="020B0604020202020204" pitchFamily="34" charset="0"/>
               <a:cs typeface="Arial" panose="020B0604020202020204" pitchFamily="34" charset="0"/>
@@ -3729,142 +3597,10 @@
   <p:cSld>
     <p:spTree>
       <p:nvGrpSpPr>
-        <p:cNvPr id="1" name=""/>
-        <p:cNvGrpSpPr/>
-        <p:nvPr/>
-      </p:nvGrpSpPr>
-      <p:grpSpPr>
-        <a:xfrm>
-          <a:off x="0" y="0"/>
-          <a:ext cx="0" cy="0"/>
-          <a:chOff x="0" y="0"/>
-          <a:chExt cx="0" cy="0"/>
-        </a:xfrm>
-      </p:grpSpPr>
-      <p:sp>
-        <p:nvSpPr>
-          <p:cNvPr id="7" name="文本框 6">
-            <a:extLst>
-              <a:ext uri="{FF2B5EF4-FFF2-40B4-BE49-F238E27FC236}">
-                <a16:creationId xmlns:a16="http://schemas.microsoft.com/office/drawing/2014/main" id="{0B924336-BE1D-805E-6FF2-A38E6E583AAE}"/>
-              </a:ext>
-            </a:extLst>
-          </p:cNvPr>
-          <p:cNvSpPr txBox="1"/>
-          <p:nvPr/>
-        </p:nvSpPr>
-        <p:spPr>
-          <a:xfrm>
-            <a:off x="479719" y="151179"/>
-            <a:ext cx="11219222" cy="584775"/>
-          </a:xfrm>
-          <a:prstGeom prst="rect">
-            <a:avLst/>
-          </a:prstGeom>
-          <a:noFill/>
-        </p:spPr>
-        <p:txBody>
-          <a:bodyPr wrap="square" rtlCol="0">
-            <a:spAutoFit/>
-          </a:bodyPr>
-          <a:lstStyle/>
-          <a:p>
-            <a:r>
-              <a:rPr lang="en-US" altLang="zh-CN" sz="3200" dirty="0">
-                <a:latin typeface="Arial" panose="020B0604020202020204" pitchFamily="34" charset="0"/>
-                <a:cs typeface="Arial" panose="020B0604020202020204" pitchFamily="34" charset="0"/>
-              </a:rPr>
-              <a:t>Experiment evaluation</a:t>
-            </a:r>
-            <a:endParaRPr lang="en-US" altLang="zh-CN" sz="2000" dirty="0">
-              <a:latin typeface="Arial" panose="020B0604020202020204" pitchFamily="34" charset="0"/>
-              <a:cs typeface="Arial" panose="020B0604020202020204" pitchFamily="34" charset="0"/>
-            </a:endParaRPr>
-          </a:p>
-        </p:txBody>
-      </p:sp>
-      <p:pic>
-        <p:nvPicPr>
-          <p:cNvPr id="4" name="图片 3" descr="图表, 条形图&#10;&#10;AI 生成的内容可能不正确。">
-            <a:extLst>
-              <a:ext uri="{FF2B5EF4-FFF2-40B4-BE49-F238E27FC236}">
-                <a16:creationId xmlns:a16="http://schemas.microsoft.com/office/drawing/2014/main" id="{FB57E768-1592-5B5F-A7B9-87E562720B9E}"/>
-              </a:ext>
-            </a:extLst>
-          </p:cNvPr>
-          <p:cNvPicPr>
-            <a:picLocks noChangeAspect="1"/>
-          </p:cNvPicPr>
-          <p:nvPr/>
-        </p:nvPicPr>
-        <p:blipFill>
-          <a:blip r:embed="rId2"/>
-          <a:stretch>
-            <a:fillRect/>
-          </a:stretch>
-        </p:blipFill>
-        <p:spPr>
-          <a:xfrm>
-            <a:off x="902510" y="735954"/>
-            <a:ext cx="4785360" cy="5189220"/>
-          </a:xfrm>
-          <a:prstGeom prst="rect">
-            <a:avLst/>
-          </a:prstGeom>
-        </p:spPr>
-      </p:pic>
-      <p:pic>
-        <p:nvPicPr>
-          <p:cNvPr id="8" name="图片 7" descr="图表, 条形图&#10;&#10;AI 生成的内容可能不正确。">
-            <a:extLst>
-              <a:ext uri="{FF2B5EF4-FFF2-40B4-BE49-F238E27FC236}">
-                <a16:creationId xmlns:a16="http://schemas.microsoft.com/office/drawing/2014/main" id="{4925B989-5A23-5FC7-C0F7-4E34F783E72E}"/>
-              </a:ext>
-            </a:extLst>
-          </p:cNvPr>
-          <p:cNvPicPr>
-            <a:picLocks noChangeAspect="1"/>
-          </p:cNvPicPr>
-          <p:nvPr/>
-        </p:nvPicPr>
-        <p:blipFill>
-          <a:blip r:embed="rId3"/>
-          <a:stretch>
-            <a:fillRect/>
-          </a:stretch>
-        </p:blipFill>
-        <p:spPr>
-          <a:xfrm>
-            <a:off x="6504130" y="735954"/>
-            <a:ext cx="4785360" cy="5189220"/>
-          </a:xfrm>
-          <a:prstGeom prst="rect">
-            <a:avLst/>
-          </a:prstGeom>
-        </p:spPr>
-      </p:pic>
-    </p:spTree>
-    <p:extLst>
-      <p:ext uri="{BB962C8B-B14F-4D97-AF65-F5344CB8AC3E}">
-        <p14:creationId xmlns:p14="http://schemas.microsoft.com/office/powerpoint/2010/main" val="2798528403"/>
-      </p:ext>
-    </p:extLst>
-  </p:cSld>
-  <p:clrMapOvr>
-    <a:masterClrMapping/>
-  </p:clrMapOvr>
-</p:sld>
-</file>
-
-<file path=ppt/slides/slide4.xml><?xml version="1.0" encoding="utf-8"?>
-<p:sld xmlns:a="http://schemas.openxmlformats.org/drawingml/2006/main" xmlns:r="http://schemas.openxmlformats.org/officeDocument/2006/relationships" xmlns:p="http://schemas.openxmlformats.org/presentationml/2006/main">
-  <p:cSld>
-    <p:spTree>
-      <p:nvGrpSpPr>
         <p:cNvPr id="1" name="">
           <a:extLst>
             <a:ext uri="{FF2B5EF4-FFF2-40B4-BE49-F238E27FC236}">
-              <a16:creationId xmlns:a16="http://schemas.microsoft.com/office/drawing/2014/main" id="{091B5B9A-31CF-8F79-EE06-A27A4F0A046B}"/>
+              <a16:creationId xmlns:a16="http://schemas.microsoft.com/office/drawing/2014/main" id="{C4FDD900-9247-17A7-AA73-6EC198B8E4EE}"/>
             </a:ext>
           </a:extLst>
         </p:cNvPr>
@@ -3879,1423 +3615,12 @@
           <a:chExt cx="0" cy="0"/>
         </a:xfrm>
       </p:grpSpPr>
-      <p:graphicFrame>
-        <p:nvGraphicFramePr>
-          <p:cNvPr id="12" name="表格 11">
-            <a:extLst>
-              <a:ext uri="{FF2B5EF4-FFF2-40B4-BE49-F238E27FC236}">
-                <a16:creationId xmlns:a16="http://schemas.microsoft.com/office/drawing/2014/main" id="{DCC2F5A7-2FAD-0E56-694F-3D8F18AB4417}"/>
-              </a:ext>
-            </a:extLst>
-          </p:cNvPr>
-          <p:cNvGraphicFramePr>
-            <a:graphicFrameLocks noGrp="1"/>
-          </p:cNvGraphicFramePr>
-          <p:nvPr>
-            <p:extLst>
-              <p:ext uri="{D42A27DB-BD31-4B8C-83A1-F6EECF244321}">
-                <p14:modId xmlns:p14="http://schemas.microsoft.com/office/powerpoint/2010/main" val="2387792478"/>
-              </p:ext>
-            </p:extLst>
-          </p:nvPr>
-        </p:nvGraphicFramePr>
-        <p:xfrm>
-          <a:off x="5473609" y="735954"/>
-          <a:ext cx="6238673" cy="1283435"/>
-        </p:xfrm>
-        <a:graphic>
-          <a:graphicData uri="http://schemas.openxmlformats.org/drawingml/2006/table">
-            <a:tbl>
-              <a:tblPr firstRow="1" bandRow="1">
-                <a:tableStyleId>{5C22544A-7EE6-4342-B048-85BDC9FD1C3A}</a:tableStyleId>
-              </a:tblPr>
-              <a:tblGrid>
-                <a:gridCol w="891239">
-                  <a:extLst>
-                    <a:ext uri="{9D8B030D-6E8A-4147-A177-3AD203B41FA5}">
-                      <a16:colId xmlns:a16="http://schemas.microsoft.com/office/drawing/2014/main" val="4101249701"/>
-                    </a:ext>
-                  </a:extLst>
-                </a:gridCol>
-                <a:gridCol w="891239">
-                  <a:extLst>
-                    <a:ext uri="{9D8B030D-6E8A-4147-A177-3AD203B41FA5}">
-                      <a16:colId xmlns:a16="http://schemas.microsoft.com/office/drawing/2014/main" val="64436008"/>
-                    </a:ext>
-                  </a:extLst>
-                </a:gridCol>
-                <a:gridCol w="891239">
-                  <a:extLst>
-                    <a:ext uri="{9D8B030D-6E8A-4147-A177-3AD203B41FA5}">
-                      <a16:colId xmlns:a16="http://schemas.microsoft.com/office/drawing/2014/main" val="2870068380"/>
-                    </a:ext>
-                  </a:extLst>
-                </a:gridCol>
-                <a:gridCol w="891239">
-                  <a:extLst>
-                    <a:ext uri="{9D8B030D-6E8A-4147-A177-3AD203B41FA5}">
-                      <a16:colId xmlns:a16="http://schemas.microsoft.com/office/drawing/2014/main" val="2903000029"/>
-                    </a:ext>
-                  </a:extLst>
-                </a:gridCol>
-                <a:gridCol w="891239">
-                  <a:extLst>
-                    <a:ext uri="{9D8B030D-6E8A-4147-A177-3AD203B41FA5}">
-                      <a16:colId xmlns:a16="http://schemas.microsoft.com/office/drawing/2014/main" val="3141391406"/>
-                    </a:ext>
-                  </a:extLst>
-                </a:gridCol>
-                <a:gridCol w="891239">
-                  <a:extLst>
-                    <a:ext uri="{9D8B030D-6E8A-4147-A177-3AD203B41FA5}">
-                      <a16:colId xmlns:a16="http://schemas.microsoft.com/office/drawing/2014/main" val="1620127239"/>
-                    </a:ext>
-                  </a:extLst>
-                </a:gridCol>
-                <a:gridCol w="891239">
-                  <a:extLst>
-                    <a:ext uri="{9D8B030D-6E8A-4147-A177-3AD203B41FA5}">
-                      <a16:colId xmlns:a16="http://schemas.microsoft.com/office/drawing/2014/main" val="2425524162"/>
-                    </a:ext>
-                  </a:extLst>
-                </a:gridCol>
-              </a:tblGrid>
-              <a:tr h="673835">
-                <a:tc>
-                  <a:txBody>
-                    <a:bodyPr/>
-                    <a:lstStyle/>
-                    <a:p>
-                      <a:r>
-                        <a:rPr lang="en-US" altLang="zh-CN" sz="1200">
-                          <a:latin typeface="Calibri" panose="020F0502020204030204" pitchFamily="34" charset="0"/>
-                          <a:ea typeface="Calibri" panose="020F0502020204030204" pitchFamily="34" charset="0"/>
-                          <a:cs typeface="Calibri" panose="020F0502020204030204" pitchFamily="34" charset="0"/>
-                        </a:rPr>
-                        <a:t>Average Token Cost</a:t>
-                      </a:r>
-                      <a:endParaRPr lang="zh-CN" altLang="en-US" sz="1200" dirty="0">
-                        <a:latin typeface="Calibri" panose="020F0502020204030204" pitchFamily="34" charset="0"/>
-                        <a:cs typeface="Calibri" panose="020F0502020204030204" pitchFamily="34" charset="0"/>
-                      </a:endParaRPr>
-                    </a:p>
-                  </a:txBody>
-                  <a:tcPr/>
-                </a:tc>
-                <a:tc>
-                  <a:txBody>
-                    <a:bodyPr/>
-                    <a:lstStyle/>
-                    <a:p>
-                      <a:pPr marL="0" marR="0" lvl="0" indent="0" algn="l" defTabSz="914400" rtl="0" eaLnBrk="1" fontAlgn="auto" latinLnBrk="0" hangingPunct="1">
-                        <a:lnSpc>
-                          <a:spcPct val="100000"/>
-                        </a:lnSpc>
-                        <a:spcBef>
-                          <a:spcPts val="0"/>
-                        </a:spcBef>
-                        <a:spcAft>
-                          <a:spcPts val="0"/>
-                        </a:spcAft>
-                        <a:buClrTx/>
-                        <a:buSzTx/>
-                        <a:buFontTx/>
-                        <a:buNone/>
-                        <a:tabLst/>
-                        <a:defRPr/>
-                      </a:pPr>
-                      <a:r>
-                        <a:rPr lang="en-US" altLang="zh-CN" sz="1200" dirty="0">
-                          <a:latin typeface="Calibri" panose="020F0502020204030204" pitchFamily="34" charset="0"/>
-                          <a:ea typeface="Calibri" panose="020F0502020204030204" pitchFamily="34" charset="0"/>
-                          <a:cs typeface="Calibri" panose="020F0502020204030204" pitchFamily="34" charset="0"/>
-                        </a:rPr>
-                        <a:t>Chain-of-Thought (</a:t>
-                      </a:r>
-                      <a:r>
-                        <a:rPr lang="en-US" altLang="zh-CN" sz="1200" dirty="0" err="1">
-                          <a:latin typeface="Calibri" panose="020F0502020204030204" pitchFamily="34" charset="0"/>
-                          <a:ea typeface="Calibri" panose="020F0502020204030204" pitchFamily="34" charset="0"/>
-                          <a:cs typeface="Calibri" panose="020F0502020204030204" pitchFamily="34" charset="0"/>
-                        </a:rPr>
-                        <a:t>CoT</a:t>
-                      </a:r>
-                      <a:r>
-                        <a:rPr lang="en-US" altLang="zh-CN" sz="1200" dirty="0">
-                          <a:latin typeface="Calibri" panose="020F0502020204030204" pitchFamily="34" charset="0"/>
-                          <a:ea typeface="Calibri" panose="020F0502020204030204" pitchFamily="34" charset="0"/>
-                          <a:cs typeface="Calibri" panose="020F0502020204030204" pitchFamily="34" charset="0"/>
-                        </a:rPr>
-                        <a:t>)</a:t>
-                      </a:r>
-                      <a:endParaRPr lang="zh-CN" altLang="en-US" sz="1200" dirty="0">
-                        <a:latin typeface="Calibri" panose="020F0502020204030204" pitchFamily="34" charset="0"/>
-                        <a:cs typeface="Calibri" panose="020F0502020204030204" pitchFamily="34" charset="0"/>
-                      </a:endParaRPr>
-                    </a:p>
-                  </a:txBody>
-                  <a:tcPr/>
-                </a:tc>
-                <a:tc>
-                  <a:txBody>
-                    <a:bodyPr/>
-                    <a:lstStyle/>
-                    <a:p>
-                      <a:pPr marL="0" marR="0" lvl="0" indent="0" algn="l" defTabSz="914400" rtl="0" eaLnBrk="1" fontAlgn="auto" latinLnBrk="0" hangingPunct="1">
-                        <a:lnSpc>
-                          <a:spcPct val="100000"/>
-                        </a:lnSpc>
-                        <a:spcBef>
-                          <a:spcPts val="0"/>
-                        </a:spcBef>
-                        <a:spcAft>
-                          <a:spcPts val="0"/>
-                        </a:spcAft>
-                        <a:buClrTx/>
-                        <a:buSzTx/>
-                        <a:buFontTx/>
-                        <a:buNone/>
-                        <a:tabLst/>
-                        <a:defRPr/>
-                      </a:pPr>
-                      <a:r>
-                        <a:rPr lang="en-US" altLang="zh-CN" sz="1200">
-                          <a:latin typeface="Calibri" panose="020F0502020204030204" pitchFamily="34" charset="0"/>
-                          <a:ea typeface="Calibri" panose="020F0502020204030204" pitchFamily="34" charset="0"/>
-                          <a:cs typeface="Calibri" panose="020F0502020204030204" pitchFamily="34" charset="0"/>
-                        </a:rPr>
-                        <a:t>Chain-of-Verification (CoVe)</a:t>
-                      </a:r>
-                      <a:endParaRPr lang="zh-CN" altLang="en-US" sz="1200" dirty="0">
-                        <a:latin typeface="Calibri" panose="020F0502020204030204" pitchFamily="34" charset="0"/>
-                        <a:cs typeface="Calibri" panose="020F0502020204030204" pitchFamily="34" charset="0"/>
-                      </a:endParaRPr>
-                    </a:p>
-                  </a:txBody>
-                  <a:tcPr/>
-                </a:tc>
-                <a:tc>
-                  <a:txBody>
-                    <a:bodyPr/>
-                    <a:lstStyle/>
-                    <a:p>
-                      <a:pPr marL="0" marR="0" lvl="0" indent="0" algn="l" defTabSz="914400" rtl="0" eaLnBrk="1" fontAlgn="auto" latinLnBrk="0" hangingPunct="1">
-                        <a:lnSpc>
-                          <a:spcPct val="100000"/>
-                        </a:lnSpc>
-                        <a:spcBef>
-                          <a:spcPts val="0"/>
-                        </a:spcBef>
-                        <a:spcAft>
-                          <a:spcPts val="0"/>
-                        </a:spcAft>
-                        <a:buClrTx/>
-                        <a:buSzTx/>
-                        <a:buFontTx/>
-                        <a:buNone/>
-                        <a:tabLst/>
-                        <a:defRPr/>
-                      </a:pPr>
-                      <a:r>
-                        <a:rPr lang="en-US" altLang="zh-CN" sz="1200">
-                          <a:latin typeface="Calibri" panose="020F0502020204030204" pitchFamily="34" charset="0"/>
-                          <a:ea typeface="Calibri" panose="020F0502020204030204" pitchFamily="34" charset="0"/>
-                          <a:cs typeface="Calibri" panose="020F0502020204030204" pitchFamily="34" charset="0"/>
-                        </a:rPr>
-                        <a:t>CoVe - Search Engine</a:t>
-                      </a:r>
-                      <a:endParaRPr lang="zh-CN" altLang="en-US" sz="1200" dirty="0">
-                        <a:latin typeface="Calibri" panose="020F0502020204030204" pitchFamily="34" charset="0"/>
-                        <a:cs typeface="Calibri" panose="020F0502020204030204" pitchFamily="34" charset="0"/>
-                      </a:endParaRPr>
-                    </a:p>
-                  </a:txBody>
-                  <a:tcPr/>
-                </a:tc>
-                <a:tc>
-                  <a:txBody>
-                    <a:bodyPr/>
-                    <a:lstStyle/>
-                    <a:p>
-                      <a:pPr marL="0" marR="0" lvl="0" indent="0" algn="l" defTabSz="914400" rtl="0" eaLnBrk="1" fontAlgn="auto" latinLnBrk="0" hangingPunct="1">
-                        <a:lnSpc>
-                          <a:spcPct val="100000"/>
-                        </a:lnSpc>
-                        <a:spcBef>
-                          <a:spcPts val="0"/>
-                        </a:spcBef>
-                        <a:spcAft>
-                          <a:spcPts val="0"/>
-                        </a:spcAft>
-                        <a:buClrTx/>
-                        <a:buSzTx/>
-                        <a:buFontTx/>
-                        <a:buNone/>
-                        <a:tabLst/>
-                        <a:defRPr/>
-                      </a:pPr>
-                      <a:r>
-                        <a:rPr lang="en-US" altLang="zh-CN" sz="1200">
-                          <a:latin typeface="Calibri" panose="020F0502020204030204" pitchFamily="34" charset="0"/>
-                          <a:ea typeface="Calibri" panose="020F0502020204030204" pitchFamily="34" charset="0"/>
-                          <a:cs typeface="Calibri" panose="020F0502020204030204" pitchFamily="34" charset="0"/>
-                        </a:rPr>
-                        <a:t>our approach</a:t>
-                      </a:r>
-                      <a:endParaRPr lang="zh-CN" altLang="en-US" sz="1200" dirty="0">
-                        <a:latin typeface="Calibri" panose="020F0502020204030204" pitchFamily="34" charset="0"/>
-                        <a:cs typeface="Calibri" panose="020F0502020204030204" pitchFamily="34" charset="0"/>
-                      </a:endParaRPr>
-                    </a:p>
-                  </a:txBody>
-                  <a:tcPr/>
-                </a:tc>
-                <a:tc>
-                  <a:txBody>
-                    <a:bodyPr/>
-                    <a:lstStyle/>
-                    <a:p>
-                      <a:pPr marL="0" marR="0" lvl="0" indent="0" algn="l" defTabSz="914400" rtl="0" eaLnBrk="1" fontAlgn="auto" latinLnBrk="0" hangingPunct="1">
-                        <a:lnSpc>
-                          <a:spcPct val="100000"/>
-                        </a:lnSpc>
-                        <a:spcBef>
-                          <a:spcPts val="0"/>
-                        </a:spcBef>
-                        <a:spcAft>
-                          <a:spcPts val="0"/>
-                        </a:spcAft>
-                        <a:buClrTx/>
-                        <a:buSzTx/>
-                        <a:buFontTx/>
-                        <a:buNone/>
-                        <a:tabLst/>
-                        <a:defRPr/>
-                      </a:pPr>
-                      <a:r>
-                        <a:rPr lang="en-US" altLang="zh-CN" sz="1200" dirty="0">
-                          <a:latin typeface="Calibri" panose="020F0502020204030204" pitchFamily="34" charset="0"/>
-                          <a:ea typeface="Calibri" panose="020F0502020204030204" pitchFamily="34" charset="0"/>
-                          <a:cs typeface="Calibri" panose="020F0502020204030204" pitchFamily="34" charset="0"/>
-                        </a:rPr>
-                        <a:t>our approach</a:t>
-                      </a:r>
-                      <a:r>
-                        <a:rPr lang="zh-CN" altLang="en-US" sz="1200" dirty="0">
-                          <a:latin typeface="Calibri" panose="020F0502020204030204" pitchFamily="34" charset="0"/>
-                          <a:cs typeface="Calibri" panose="020F0502020204030204" pitchFamily="34" charset="0"/>
-                        </a:rPr>
-                        <a:t> </a:t>
-                      </a:r>
-                      <a:r>
-                        <a:rPr lang="en-US" altLang="zh-CN" sz="1200" dirty="0">
-                          <a:latin typeface="Calibri" panose="020F0502020204030204" pitchFamily="34" charset="0"/>
-                          <a:ea typeface="Calibri" panose="020F0502020204030204" pitchFamily="34" charset="0"/>
-                          <a:cs typeface="Calibri" panose="020F0502020204030204" pitchFamily="34" charset="0"/>
-                        </a:rPr>
-                        <a:t>- mutations</a:t>
-                      </a:r>
-                      <a:endParaRPr lang="zh-CN" altLang="en-US" sz="1200" dirty="0">
-                        <a:latin typeface="Calibri" panose="020F0502020204030204" pitchFamily="34" charset="0"/>
-                        <a:cs typeface="Calibri" panose="020F0502020204030204" pitchFamily="34" charset="0"/>
-                      </a:endParaRPr>
-                    </a:p>
-                  </a:txBody>
-                  <a:tcPr/>
-                </a:tc>
-                <a:tc>
-                  <a:txBody>
-                    <a:bodyPr/>
-                    <a:lstStyle/>
-                    <a:p>
-                      <a:pPr marL="0" marR="0" lvl="0" indent="0" algn="l" defTabSz="914400" rtl="0" eaLnBrk="1" fontAlgn="auto" latinLnBrk="0" hangingPunct="1">
-                        <a:lnSpc>
-                          <a:spcPct val="100000"/>
-                        </a:lnSpc>
-                        <a:spcBef>
-                          <a:spcPts val="0"/>
-                        </a:spcBef>
-                        <a:spcAft>
-                          <a:spcPts val="0"/>
-                        </a:spcAft>
-                        <a:buClrTx/>
-                        <a:buSzTx/>
-                        <a:buFontTx/>
-                        <a:buNone/>
-                        <a:tabLst/>
-                        <a:defRPr/>
-                      </a:pPr>
-                      <a:r>
-                        <a:rPr lang="en-US" altLang="zh-CN" sz="1200" dirty="0">
-                          <a:latin typeface="Calibri" panose="020F0502020204030204" pitchFamily="34" charset="0"/>
-                          <a:cs typeface="Calibri" panose="020F0502020204030204" pitchFamily="34" charset="0"/>
-                        </a:rPr>
-                        <a:t>our approach - vs</a:t>
-                      </a:r>
-                      <a:endParaRPr lang="zh-CN" altLang="en-US" sz="1200" dirty="0">
-                        <a:latin typeface="Calibri" panose="020F0502020204030204" pitchFamily="34" charset="0"/>
-                        <a:cs typeface="Calibri" panose="020F0502020204030204" pitchFamily="34" charset="0"/>
-                      </a:endParaRPr>
-                    </a:p>
-                  </a:txBody>
-                  <a:tcPr/>
-                </a:tc>
-                <a:extLst>
-                  <a:ext uri="{0D108BD9-81ED-4DB2-BD59-A6C34878D82A}">
-                    <a16:rowId xmlns:a16="http://schemas.microsoft.com/office/drawing/2014/main" val="3466647714"/>
-                  </a:ext>
-                </a:extLst>
-              </a:tr>
-              <a:tr h="280765">
-                <a:tc>
-                  <a:txBody>
-                    <a:bodyPr/>
-                    <a:lstStyle/>
-                    <a:p>
-                      <a:pPr algn="ctr"/>
-                      <a:r>
-                        <a:rPr lang="en-US" altLang="zh-CN" sz="1400">
-                          <a:latin typeface="Arial" panose="020B0604020202020204" pitchFamily="34" charset="0"/>
-                          <a:cs typeface="Arial" panose="020B0604020202020204" pitchFamily="34" charset="0"/>
-                        </a:rPr>
-                        <a:t>gpt-4o</a:t>
-                      </a:r>
-                      <a:endParaRPr lang="zh-CN" altLang="en-US" sz="1400" dirty="0">
-                        <a:latin typeface="Arial" panose="020B0604020202020204" pitchFamily="34" charset="0"/>
-                        <a:cs typeface="Arial" panose="020B0604020202020204" pitchFamily="34" charset="0"/>
-                      </a:endParaRPr>
-                    </a:p>
-                  </a:txBody>
-                  <a:tcPr/>
-                </a:tc>
-                <a:tc>
-                  <a:txBody>
-                    <a:bodyPr/>
-                    <a:lstStyle/>
-                    <a:p>
-                      <a:pPr algn="ctr"/>
-                      <a:r>
-                        <a:rPr lang="en-US" altLang="zh-CN" sz="1400">
-                          <a:latin typeface="Arial" panose="020B0604020202020204" pitchFamily="34" charset="0"/>
-                          <a:cs typeface="Arial" panose="020B0604020202020204" pitchFamily="34" charset="0"/>
-                        </a:rPr>
-                        <a:t>101.73</a:t>
-                      </a:r>
-                      <a:endParaRPr lang="zh-CN" altLang="en-US" sz="1400" dirty="0">
-                        <a:latin typeface="Arial" panose="020B0604020202020204" pitchFamily="34" charset="0"/>
-                        <a:cs typeface="Arial" panose="020B0604020202020204" pitchFamily="34" charset="0"/>
-                      </a:endParaRPr>
-                    </a:p>
-                  </a:txBody>
-                  <a:tcPr/>
-                </a:tc>
-                <a:tc>
-                  <a:txBody>
-                    <a:bodyPr/>
-                    <a:lstStyle/>
-                    <a:p>
-                      <a:pPr algn="ctr"/>
-                      <a:r>
-                        <a:rPr lang="en-US" altLang="zh-CN" sz="1400">
-                          <a:latin typeface="Arial" panose="020B0604020202020204" pitchFamily="34" charset="0"/>
-                          <a:cs typeface="Arial" panose="020B0604020202020204" pitchFamily="34" charset="0"/>
-                        </a:rPr>
-                        <a:t>2633.25</a:t>
-                      </a:r>
-                      <a:endParaRPr lang="zh-CN" altLang="en-US" sz="1400" dirty="0">
-                        <a:latin typeface="Arial" panose="020B0604020202020204" pitchFamily="34" charset="0"/>
-                        <a:cs typeface="Arial" panose="020B0604020202020204" pitchFamily="34" charset="0"/>
-                      </a:endParaRPr>
-                    </a:p>
-                  </a:txBody>
-                  <a:tcPr/>
-                </a:tc>
-                <a:tc>
-                  <a:txBody>
-                    <a:bodyPr/>
-                    <a:lstStyle/>
-                    <a:p>
-                      <a:pPr algn="ctr"/>
-                      <a:r>
-                        <a:rPr lang="en-US" altLang="zh-CN" sz="1400" dirty="0">
-                          <a:latin typeface="Arial" panose="020B0604020202020204" pitchFamily="34" charset="0"/>
-                          <a:cs typeface="Arial" panose="020B0604020202020204" pitchFamily="34" charset="0"/>
-                        </a:rPr>
-                        <a:t>3808.19</a:t>
-                      </a:r>
-                      <a:endParaRPr lang="zh-CN" altLang="en-US" sz="1400" dirty="0">
-                        <a:latin typeface="Arial" panose="020B0604020202020204" pitchFamily="34" charset="0"/>
-                        <a:cs typeface="Arial" panose="020B0604020202020204" pitchFamily="34" charset="0"/>
-                      </a:endParaRPr>
-                    </a:p>
-                  </a:txBody>
-                  <a:tcPr/>
-                </a:tc>
-                <a:tc>
-                  <a:txBody>
-                    <a:bodyPr/>
-                    <a:lstStyle/>
-                    <a:p>
-                      <a:pPr algn="ctr"/>
-                      <a:r>
-                        <a:rPr lang="en-US" altLang="zh-CN" sz="1400" dirty="0">
-                          <a:latin typeface="Arial" panose="020B0604020202020204" pitchFamily="34" charset="0"/>
-                          <a:cs typeface="Arial" panose="020B0604020202020204" pitchFamily="34" charset="0"/>
-                        </a:rPr>
-                        <a:t>197.15</a:t>
-                      </a:r>
-                      <a:endParaRPr lang="zh-CN" altLang="en-US" sz="1400" dirty="0">
-                        <a:latin typeface="Arial" panose="020B0604020202020204" pitchFamily="34" charset="0"/>
-                        <a:cs typeface="Arial" panose="020B0604020202020204" pitchFamily="34" charset="0"/>
-                      </a:endParaRPr>
-                    </a:p>
-                  </a:txBody>
-                  <a:tcPr/>
-                </a:tc>
-                <a:tc>
-                  <a:txBody>
-                    <a:bodyPr/>
-                    <a:lstStyle/>
-                    <a:p>
-                      <a:pPr algn="ctr"/>
-                      <a:r>
-                        <a:rPr lang="en-US" altLang="zh-CN" sz="1400" dirty="0">
-                          <a:latin typeface="Arial" panose="020B0604020202020204" pitchFamily="34" charset="0"/>
-                          <a:cs typeface="Arial" panose="020B0604020202020204" pitchFamily="34" charset="0"/>
-                        </a:rPr>
-                        <a:t>1763.87</a:t>
-                      </a:r>
-                      <a:endParaRPr lang="zh-CN" altLang="en-US" sz="1400" dirty="0">
-                        <a:latin typeface="Arial" panose="020B0604020202020204" pitchFamily="34" charset="0"/>
-                        <a:cs typeface="Arial" panose="020B0604020202020204" pitchFamily="34" charset="0"/>
-                      </a:endParaRPr>
-                    </a:p>
-                  </a:txBody>
-                  <a:tcPr/>
-                </a:tc>
-                <a:tc>
-                  <a:txBody>
-                    <a:bodyPr/>
-                    <a:lstStyle/>
-                    <a:p>
-                      <a:pPr algn="ctr"/>
-                      <a:r>
-                        <a:rPr lang="en-US" altLang="zh-CN" sz="1400" dirty="0">
-                          <a:latin typeface="Arial" panose="020B0604020202020204" pitchFamily="34" charset="0"/>
-                          <a:cs typeface="Arial" panose="020B0604020202020204" pitchFamily="34" charset="0"/>
-                        </a:rPr>
-                        <a:t>596.13</a:t>
-                      </a:r>
-                      <a:endParaRPr lang="zh-CN" altLang="en-US" sz="1400" dirty="0">
-                        <a:latin typeface="Arial" panose="020B0604020202020204" pitchFamily="34" charset="0"/>
-                        <a:cs typeface="Arial" panose="020B0604020202020204" pitchFamily="34" charset="0"/>
-                      </a:endParaRPr>
-                    </a:p>
-                  </a:txBody>
-                  <a:tcPr/>
-                </a:tc>
-                <a:extLst>
-                  <a:ext uri="{0D108BD9-81ED-4DB2-BD59-A6C34878D82A}">
-                    <a16:rowId xmlns:a16="http://schemas.microsoft.com/office/drawing/2014/main" val="971162633"/>
-                  </a:ext>
-                </a:extLst>
-              </a:tr>
-              <a:tr h="280765">
-                <a:tc>
-                  <a:txBody>
-                    <a:bodyPr/>
-                    <a:lstStyle/>
-                    <a:p>
-                      <a:pPr algn="ctr"/>
-                      <a:r>
-                        <a:rPr lang="en-US" altLang="zh-CN" sz="1400" dirty="0">
-                          <a:latin typeface="Arial" panose="020B0604020202020204" pitchFamily="34" charset="0"/>
-                          <a:cs typeface="Arial" panose="020B0604020202020204" pitchFamily="34" charset="0"/>
-                        </a:rPr>
-                        <a:t>gpt-5</a:t>
-                      </a:r>
-                      <a:endParaRPr lang="zh-CN" altLang="en-US" sz="1400" dirty="0">
-                        <a:latin typeface="Arial" panose="020B0604020202020204" pitchFamily="34" charset="0"/>
-                        <a:cs typeface="Arial" panose="020B0604020202020204" pitchFamily="34" charset="0"/>
-                      </a:endParaRPr>
-                    </a:p>
-                  </a:txBody>
-                  <a:tcPr/>
-                </a:tc>
-                <a:tc>
-                  <a:txBody>
-                    <a:bodyPr/>
-                    <a:lstStyle/>
-                    <a:p>
-                      <a:pPr algn="ctr"/>
-                      <a:r>
-                        <a:rPr lang="en-US" altLang="zh-CN" sz="1400" dirty="0">
-                          <a:latin typeface="Arial" panose="020B0604020202020204" pitchFamily="34" charset="0"/>
-                          <a:cs typeface="Arial" panose="020B0604020202020204" pitchFamily="34" charset="0"/>
-                        </a:rPr>
-                        <a:t>87.03</a:t>
-                      </a:r>
-                      <a:endParaRPr lang="zh-CN" altLang="en-US" sz="1400" dirty="0">
-                        <a:latin typeface="Arial" panose="020B0604020202020204" pitchFamily="34" charset="0"/>
-                        <a:cs typeface="Arial" panose="020B0604020202020204" pitchFamily="34" charset="0"/>
-                      </a:endParaRPr>
-                    </a:p>
-                  </a:txBody>
-                  <a:tcPr/>
-                </a:tc>
-                <a:tc>
-                  <a:txBody>
-                    <a:bodyPr/>
-                    <a:lstStyle/>
-                    <a:p>
-                      <a:pPr algn="ctr"/>
-                      <a:r>
-                        <a:rPr lang="en-US" altLang="zh-CN" sz="1400" dirty="0">
-                          <a:latin typeface="Arial" panose="020B0604020202020204" pitchFamily="34" charset="0"/>
-                          <a:cs typeface="Arial" panose="020B0604020202020204" pitchFamily="34" charset="0"/>
-                        </a:rPr>
-                        <a:t>6824.61</a:t>
-                      </a:r>
-                      <a:endParaRPr lang="zh-CN" altLang="en-US" sz="1400" dirty="0">
-                        <a:latin typeface="Arial" panose="020B0604020202020204" pitchFamily="34" charset="0"/>
-                        <a:cs typeface="Arial" panose="020B0604020202020204" pitchFamily="34" charset="0"/>
-                      </a:endParaRPr>
-                    </a:p>
-                  </a:txBody>
-                  <a:tcPr/>
-                </a:tc>
-                <a:tc>
-                  <a:txBody>
-                    <a:bodyPr/>
-                    <a:lstStyle/>
-                    <a:p>
-                      <a:pPr algn="ctr"/>
-                      <a:r>
-                        <a:rPr lang="en-US" altLang="zh-CN" sz="1400" dirty="0">
-                          <a:latin typeface="Arial" panose="020B0604020202020204" pitchFamily="34" charset="0"/>
-                          <a:cs typeface="Arial" panose="020B0604020202020204" pitchFamily="34" charset="0"/>
-                        </a:rPr>
-                        <a:t>7828.29</a:t>
-                      </a:r>
-                      <a:endParaRPr lang="zh-CN" altLang="en-US" sz="1400" dirty="0">
-                        <a:latin typeface="Arial" panose="020B0604020202020204" pitchFamily="34" charset="0"/>
-                        <a:cs typeface="Arial" panose="020B0604020202020204" pitchFamily="34" charset="0"/>
-                      </a:endParaRPr>
-                    </a:p>
-                  </a:txBody>
-                  <a:tcPr/>
-                </a:tc>
-                <a:tc>
-                  <a:txBody>
-                    <a:bodyPr/>
-                    <a:lstStyle/>
-                    <a:p>
-                      <a:pPr algn="ctr"/>
-                      <a:r>
-                        <a:rPr lang="en-US" altLang="zh-CN" sz="1400" dirty="0">
-                          <a:latin typeface="Arial" panose="020B0604020202020204" pitchFamily="34" charset="0"/>
-                          <a:cs typeface="Arial" panose="020B0604020202020204" pitchFamily="34" charset="0"/>
-                        </a:rPr>
-                        <a:t>188.51</a:t>
-                      </a:r>
-                      <a:endParaRPr lang="zh-CN" altLang="en-US" sz="1400" dirty="0">
-                        <a:latin typeface="Arial" panose="020B0604020202020204" pitchFamily="34" charset="0"/>
-                        <a:cs typeface="Arial" panose="020B0604020202020204" pitchFamily="34" charset="0"/>
-                      </a:endParaRPr>
-                    </a:p>
-                  </a:txBody>
-                  <a:tcPr/>
-                </a:tc>
-                <a:tc>
-                  <a:txBody>
-                    <a:bodyPr/>
-                    <a:lstStyle/>
-                    <a:p>
-                      <a:pPr algn="ctr"/>
-                      <a:r>
-                        <a:rPr lang="en-US" altLang="zh-CN" sz="1400" dirty="0">
-                          <a:latin typeface="Arial" panose="020B0604020202020204" pitchFamily="34" charset="0"/>
-                          <a:cs typeface="Arial" panose="020B0604020202020204" pitchFamily="34" charset="0"/>
-                        </a:rPr>
-                        <a:t>1775.89</a:t>
-                      </a:r>
-                      <a:endParaRPr lang="zh-CN" altLang="en-US" sz="1400" dirty="0">
-                        <a:latin typeface="Arial" panose="020B0604020202020204" pitchFamily="34" charset="0"/>
-                        <a:cs typeface="Arial" panose="020B0604020202020204" pitchFamily="34" charset="0"/>
-                      </a:endParaRPr>
-                    </a:p>
-                  </a:txBody>
-                  <a:tcPr/>
-                </a:tc>
-                <a:tc>
-                  <a:txBody>
-                    <a:bodyPr/>
-                    <a:lstStyle/>
-                    <a:p>
-                      <a:pPr algn="ctr"/>
-                      <a:r>
-                        <a:rPr lang="en-US" altLang="zh-CN" sz="1400" dirty="0">
-                          <a:latin typeface="Arial" panose="020B0604020202020204" pitchFamily="34" charset="0"/>
-                          <a:cs typeface="Arial" panose="020B0604020202020204" pitchFamily="34" charset="0"/>
-                        </a:rPr>
-                        <a:t>580.05</a:t>
-                      </a:r>
-                      <a:endParaRPr lang="zh-CN" altLang="en-US" sz="1400" dirty="0">
-                        <a:latin typeface="Arial" panose="020B0604020202020204" pitchFamily="34" charset="0"/>
-                        <a:cs typeface="Arial" panose="020B0604020202020204" pitchFamily="34" charset="0"/>
-                      </a:endParaRPr>
-                    </a:p>
-                  </a:txBody>
-                  <a:tcPr/>
-                </a:tc>
-                <a:extLst>
-                  <a:ext uri="{0D108BD9-81ED-4DB2-BD59-A6C34878D82A}">
-                    <a16:rowId xmlns:a16="http://schemas.microsoft.com/office/drawing/2014/main" val="2166985772"/>
-                  </a:ext>
-                </a:extLst>
-              </a:tr>
-            </a:tbl>
-          </a:graphicData>
-        </a:graphic>
-      </p:graphicFrame>
-      <p:graphicFrame>
-        <p:nvGraphicFramePr>
-          <p:cNvPr id="13" name="表格 12">
-            <a:extLst>
-              <a:ext uri="{FF2B5EF4-FFF2-40B4-BE49-F238E27FC236}">
-                <a16:creationId xmlns:a16="http://schemas.microsoft.com/office/drawing/2014/main" id="{469CD08E-F3B2-84D2-93AA-148551C0EF3C}"/>
-              </a:ext>
-            </a:extLst>
-          </p:cNvPr>
-          <p:cNvGraphicFramePr>
-            <a:graphicFrameLocks noGrp="1"/>
-          </p:cNvGraphicFramePr>
-          <p:nvPr>
-            <p:extLst>
-              <p:ext uri="{D42A27DB-BD31-4B8C-83A1-F6EECF244321}">
-                <p14:modId xmlns:p14="http://schemas.microsoft.com/office/powerpoint/2010/main" val="295088838"/>
-              </p:ext>
-            </p:extLst>
-          </p:nvPr>
-        </p:nvGraphicFramePr>
-        <p:xfrm>
-          <a:off x="5473609" y="2019389"/>
-          <a:ext cx="6225331" cy="1276241"/>
-        </p:xfrm>
-        <a:graphic>
-          <a:graphicData uri="http://schemas.openxmlformats.org/drawingml/2006/table">
-            <a:tbl>
-              <a:tblPr firstRow="1" bandRow="1">
-                <a:tableStyleId>{5C22544A-7EE6-4342-B048-85BDC9FD1C3A}</a:tableStyleId>
-              </a:tblPr>
-              <a:tblGrid>
-                <a:gridCol w="889333">
-                  <a:extLst>
-                    <a:ext uri="{9D8B030D-6E8A-4147-A177-3AD203B41FA5}">
-                      <a16:colId xmlns:a16="http://schemas.microsoft.com/office/drawing/2014/main" val="4101249701"/>
-                    </a:ext>
-                  </a:extLst>
-                </a:gridCol>
-                <a:gridCol w="889333">
-                  <a:extLst>
-                    <a:ext uri="{9D8B030D-6E8A-4147-A177-3AD203B41FA5}">
-                      <a16:colId xmlns:a16="http://schemas.microsoft.com/office/drawing/2014/main" val="64436008"/>
-                    </a:ext>
-                  </a:extLst>
-                </a:gridCol>
-                <a:gridCol w="889333">
-                  <a:extLst>
-                    <a:ext uri="{9D8B030D-6E8A-4147-A177-3AD203B41FA5}">
-                      <a16:colId xmlns:a16="http://schemas.microsoft.com/office/drawing/2014/main" val="2870068380"/>
-                    </a:ext>
-                  </a:extLst>
-                </a:gridCol>
-                <a:gridCol w="889333">
-                  <a:extLst>
-                    <a:ext uri="{9D8B030D-6E8A-4147-A177-3AD203B41FA5}">
-                      <a16:colId xmlns:a16="http://schemas.microsoft.com/office/drawing/2014/main" val="2903000029"/>
-                    </a:ext>
-                  </a:extLst>
-                </a:gridCol>
-                <a:gridCol w="889333">
-                  <a:extLst>
-                    <a:ext uri="{9D8B030D-6E8A-4147-A177-3AD203B41FA5}">
-                      <a16:colId xmlns:a16="http://schemas.microsoft.com/office/drawing/2014/main" val="3141391406"/>
-                    </a:ext>
-                  </a:extLst>
-                </a:gridCol>
-                <a:gridCol w="889333">
-                  <a:extLst>
-                    <a:ext uri="{9D8B030D-6E8A-4147-A177-3AD203B41FA5}">
-                      <a16:colId xmlns:a16="http://schemas.microsoft.com/office/drawing/2014/main" val="4228366896"/>
-                    </a:ext>
-                  </a:extLst>
-                </a:gridCol>
-                <a:gridCol w="889333">
-                  <a:extLst>
-                    <a:ext uri="{9D8B030D-6E8A-4147-A177-3AD203B41FA5}">
-                      <a16:colId xmlns:a16="http://schemas.microsoft.com/office/drawing/2014/main" val="3963888700"/>
-                    </a:ext>
-                  </a:extLst>
-                </a:gridCol>
-              </a:tblGrid>
-              <a:tr h="666641">
-                <a:tc>
-                  <a:txBody>
-                    <a:bodyPr/>
-                    <a:lstStyle/>
-                    <a:p>
-                      <a:pPr marL="0" marR="0" lvl="0" indent="0" algn="l" defTabSz="914400" rtl="0" eaLnBrk="1" fontAlgn="auto" latinLnBrk="0" hangingPunct="1">
-                        <a:lnSpc>
-                          <a:spcPct val="100000"/>
-                        </a:lnSpc>
-                        <a:spcBef>
-                          <a:spcPts val="0"/>
-                        </a:spcBef>
-                        <a:spcAft>
-                          <a:spcPts val="0"/>
-                        </a:spcAft>
-                        <a:buClrTx/>
-                        <a:buSzTx/>
-                        <a:buFontTx/>
-                        <a:buNone/>
-                        <a:tabLst/>
-                        <a:defRPr/>
-                      </a:pPr>
-                      <a:r>
-                        <a:rPr lang="en-US" altLang="zh-CN" sz="1200" dirty="0">
-                          <a:latin typeface="Calibri" panose="020F0502020204030204" pitchFamily="34" charset="0"/>
-                          <a:ea typeface="Calibri" panose="020F0502020204030204" pitchFamily="34" charset="0"/>
-                          <a:cs typeface="Calibri" panose="020F0502020204030204" pitchFamily="34" charset="0"/>
-                        </a:rPr>
-                        <a:t>Average Time Cost</a:t>
-                      </a:r>
-                      <a:endParaRPr lang="zh-CN" altLang="en-US" sz="1200" dirty="0">
-                        <a:latin typeface="Calibri" panose="020F0502020204030204" pitchFamily="34" charset="0"/>
-                        <a:cs typeface="Calibri" panose="020F0502020204030204" pitchFamily="34" charset="0"/>
-                      </a:endParaRPr>
-                    </a:p>
-                  </a:txBody>
-                  <a:tcPr/>
-                </a:tc>
-                <a:tc>
-                  <a:txBody>
-                    <a:bodyPr/>
-                    <a:lstStyle/>
-                    <a:p>
-                      <a:pPr marL="0" marR="0" lvl="0" indent="0" algn="l" defTabSz="914400" rtl="0" eaLnBrk="1" fontAlgn="auto" latinLnBrk="0" hangingPunct="1">
-                        <a:lnSpc>
-                          <a:spcPct val="100000"/>
-                        </a:lnSpc>
-                        <a:spcBef>
-                          <a:spcPts val="0"/>
-                        </a:spcBef>
-                        <a:spcAft>
-                          <a:spcPts val="0"/>
-                        </a:spcAft>
-                        <a:buClrTx/>
-                        <a:buSzTx/>
-                        <a:buFontTx/>
-                        <a:buNone/>
-                        <a:tabLst/>
-                        <a:defRPr/>
-                      </a:pPr>
-                      <a:r>
-                        <a:rPr lang="en-US" altLang="zh-CN" sz="1200" dirty="0">
-                          <a:latin typeface="Calibri" panose="020F0502020204030204" pitchFamily="34" charset="0"/>
-                          <a:ea typeface="Calibri" panose="020F0502020204030204" pitchFamily="34" charset="0"/>
-                          <a:cs typeface="Calibri" panose="020F0502020204030204" pitchFamily="34" charset="0"/>
-                        </a:rPr>
-                        <a:t>Chain-of-Thought (</a:t>
-                      </a:r>
-                      <a:r>
-                        <a:rPr lang="en-US" altLang="zh-CN" sz="1200" dirty="0" err="1">
-                          <a:latin typeface="Calibri" panose="020F0502020204030204" pitchFamily="34" charset="0"/>
-                          <a:ea typeface="Calibri" panose="020F0502020204030204" pitchFamily="34" charset="0"/>
-                          <a:cs typeface="Calibri" panose="020F0502020204030204" pitchFamily="34" charset="0"/>
-                        </a:rPr>
-                        <a:t>CoT</a:t>
-                      </a:r>
-                      <a:r>
-                        <a:rPr lang="en-US" altLang="zh-CN" sz="1200" dirty="0">
-                          <a:latin typeface="Calibri" panose="020F0502020204030204" pitchFamily="34" charset="0"/>
-                          <a:ea typeface="Calibri" panose="020F0502020204030204" pitchFamily="34" charset="0"/>
-                          <a:cs typeface="Calibri" panose="020F0502020204030204" pitchFamily="34" charset="0"/>
-                        </a:rPr>
-                        <a:t>)</a:t>
-                      </a:r>
-                      <a:endParaRPr lang="zh-CN" altLang="en-US" sz="1200" dirty="0">
-                        <a:latin typeface="Calibri" panose="020F0502020204030204" pitchFamily="34" charset="0"/>
-                        <a:cs typeface="Calibri" panose="020F0502020204030204" pitchFamily="34" charset="0"/>
-                      </a:endParaRPr>
-                    </a:p>
-                  </a:txBody>
-                  <a:tcPr/>
-                </a:tc>
-                <a:tc>
-                  <a:txBody>
-                    <a:bodyPr/>
-                    <a:lstStyle/>
-                    <a:p>
-                      <a:pPr marL="0" marR="0" lvl="0" indent="0" algn="l" defTabSz="914400" rtl="0" eaLnBrk="1" fontAlgn="auto" latinLnBrk="0" hangingPunct="1">
-                        <a:lnSpc>
-                          <a:spcPct val="100000"/>
-                        </a:lnSpc>
-                        <a:spcBef>
-                          <a:spcPts val="0"/>
-                        </a:spcBef>
-                        <a:spcAft>
-                          <a:spcPts val="0"/>
-                        </a:spcAft>
-                        <a:buClrTx/>
-                        <a:buSzTx/>
-                        <a:buFontTx/>
-                        <a:buNone/>
-                        <a:tabLst/>
-                        <a:defRPr/>
-                      </a:pPr>
-                      <a:r>
-                        <a:rPr lang="en-US" altLang="zh-CN" sz="1200" dirty="0">
-                          <a:latin typeface="Calibri" panose="020F0502020204030204" pitchFamily="34" charset="0"/>
-                          <a:ea typeface="Calibri" panose="020F0502020204030204" pitchFamily="34" charset="0"/>
-                          <a:cs typeface="Calibri" panose="020F0502020204030204" pitchFamily="34" charset="0"/>
-                        </a:rPr>
-                        <a:t>Chain-of-Verification (</a:t>
-                      </a:r>
-                      <a:r>
-                        <a:rPr lang="en-US" altLang="zh-CN" sz="1200" dirty="0" err="1">
-                          <a:latin typeface="Calibri" panose="020F0502020204030204" pitchFamily="34" charset="0"/>
-                          <a:ea typeface="Calibri" panose="020F0502020204030204" pitchFamily="34" charset="0"/>
-                          <a:cs typeface="Calibri" panose="020F0502020204030204" pitchFamily="34" charset="0"/>
-                        </a:rPr>
-                        <a:t>CoVe</a:t>
-                      </a:r>
-                      <a:r>
-                        <a:rPr lang="en-US" altLang="zh-CN" sz="1200" dirty="0">
-                          <a:latin typeface="Calibri" panose="020F0502020204030204" pitchFamily="34" charset="0"/>
-                          <a:ea typeface="Calibri" panose="020F0502020204030204" pitchFamily="34" charset="0"/>
-                          <a:cs typeface="Calibri" panose="020F0502020204030204" pitchFamily="34" charset="0"/>
-                        </a:rPr>
-                        <a:t>)</a:t>
-                      </a:r>
-                      <a:endParaRPr lang="zh-CN" altLang="en-US" sz="1200" dirty="0">
-                        <a:latin typeface="Calibri" panose="020F0502020204030204" pitchFamily="34" charset="0"/>
-                        <a:cs typeface="Calibri" panose="020F0502020204030204" pitchFamily="34" charset="0"/>
-                      </a:endParaRPr>
-                    </a:p>
-                  </a:txBody>
-                  <a:tcPr/>
-                </a:tc>
-                <a:tc>
-                  <a:txBody>
-                    <a:bodyPr/>
-                    <a:lstStyle/>
-                    <a:p>
-                      <a:pPr marL="0" marR="0" lvl="0" indent="0" algn="l" defTabSz="914400" rtl="0" eaLnBrk="1" fontAlgn="auto" latinLnBrk="0" hangingPunct="1">
-                        <a:lnSpc>
-                          <a:spcPct val="100000"/>
-                        </a:lnSpc>
-                        <a:spcBef>
-                          <a:spcPts val="0"/>
-                        </a:spcBef>
-                        <a:spcAft>
-                          <a:spcPts val="0"/>
-                        </a:spcAft>
-                        <a:buClrTx/>
-                        <a:buSzTx/>
-                        <a:buFontTx/>
-                        <a:buNone/>
-                        <a:tabLst/>
-                        <a:defRPr/>
-                      </a:pPr>
-                      <a:r>
-                        <a:rPr lang="en-US" altLang="zh-CN" sz="1200" dirty="0" err="1">
-                          <a:latin typeface="Calibri" panose="020F0502020204030204" pitchFamily="34" charset="0"/>
-                          <a:ea typeface="Calibri" panose="020F0502020204030204" pitchFamily="34" charset="0"/>
-                          <a:cs typeface="Calibri" panose="020F0502020204030204" pitchFamily="34" charset="0"/>
-                        </a:rPr>
-                        <a:t>CoVe</a:t>
-                      </a:r>
-                      <a:r>
-                        <a:rPr lang="en-US" altLang="zh-CN" sz="1200" dirty="0">
-                          <a:latin typeface="Calibri" panose="020F0502020204030204" pitchFamily="34" charset="0"/>
-                          <a:ea typeface="Calibri" panose="020F0502020204030204" pitchFamily="34" charset="0"/>
-                          <a:cs typeface="Calibri" panose="020F0502020204030204" pitchFamily="34" charset="0"/>
-                        </a:rPr>
-                        <a:t> - Search Engine</a:t>
-                      </a:r>
-                      <a:endParaRPr lang="zh-CN" altLang="en-US" sz="1200" dirty="0">
-                        <a:latin typeface="Calibri" panose="020F0502020204030204" pitchFamily="34" charset="0"/>
-                        <a:cs typeface="Calibri" panose="020F0502020204030204" pitchFamily="34" charset="0"/>
-                      </a:endParaRPr>
-                    </a:p>
-                  </a:txBody>
-                  <a:tcPr/>
-                </a:tc>
-                <a:tc>
-                  <a:txBody>
-                    <a:bodyPr/>
-                    <a:lstStyle/>
-                    <a:p>
-                      <a:pPr marL="0" marR="0" lvl="0" indent="0" algn="l" defTabSz="914400" rtl="0" eaLnBrk="1" fontAlgn="auto" latinLnBrk="0" hangingPunct="1">
-                        <a:lnSpc>
-                          <a:spcPct val="100000"/>
-                        </a:lnSpc>
-                        <a:spcBef>
-                          <a:spcPts val="0"/>
-                        </a:spcBef>
-                        <a:spcAft>
-                          <a:spcPts val="0"/>
-                        </a:spcAft>
-                        <a:buClrTx/>
-                        <a:buSzTx/>
-                        <a:buFontTx/>
-                        <a:buNone/>
-                        <a:tabLst/>
-                        <a:defRPr/>
-                      </a:pPr>
-                      <a:r>
-                        <a:rPr lang="en-US" altLang="zh-CN" sz="1200" dirty="0">
-                          <a:latin typeface="Calibri" panose="020F0502020204030204" pitchFamily="34" charset="0"/>
-                          <a:ea typeface="Calibri" panose="020F0502020204030204" pitchFamily="34" charset="0"/>
-                          <a:cs typeface="Calibri" panose="020F0502020204030204" pitchFamily="34" charset="0"/>
-                        </a:rPr>
-                        <a:t>our approach</a:t>
-                      </a:r>
-                      <a:endParaRPr lang="zh-CN" altLang="en-US" sz="1200" dirty="0">
-                        <a:latin typeface="Calibri" panose="020F0502020204030204" pitchFamily="34" charset="0"/>
-                        <a:cs typeface="Calibri" panose="020F0502020204030204" pitchFamily="34" charset="0"/>
-                      </a:endParaRPr>
-                    </a:p>
-                  </a:txBody>
-                  <a:tcPr/>
-                </a:tc>
-                <a:tc>
-                  <a:txBody>
-                    <a:bodyPr/>
-                    <a:lstStyle/>
-                    <a:p>
-                      <a:pPr marL="0" marR="0" lvl="0" indent="0" algn="l" defTabSz="914400" rtl="0" eaLnBrk="1" fontAlgn="auto" latinLnBrk="0" hangingPunct="1">
-                        <a:lnSpc>
-                          <a:spcPct val="100000"/>
-                        </a:lnSpc>
-                        <a:spcBef>
-                          <a:spcPts val="0"/>
-                        </a:spcBef>
-                        <a:spcAft>
-                          <a:spcPts val="0"/>
-                        </a:spcAft>
-                        <a:buClrTx/>
-                        <a:buSzTx/>
-                        <a:buFontTx/>
-                        <a:buNone/>
-                        <a:tabLst/>
-                        <a:defRPr/>
-                      </a:pPr>
-                      <a:r>
-                        <a:rPr lang="en-US" altLang="zh-CN" sz="1200" dirty="0">
-                          <a:latin typeface="Calibri" panose="020F0502020204030204" pitchFamily="34" charset="0"/>
-                          <a:ea typeface="Calibri" panose="020F0502020204030204" pitchFamily="34" charset="0"/>
-                          <a:cs typeface="Calibri" panose="020F0502020204030204" pitchFamily="34" charset="0"/>
-                        </a:rPr>
-                        <a:t>our approach</a:t>
-                      </a:r>
-                      <a:r>
-                        <a:rPr lang="zh-CN" altLang="en-US" sz="1200" dirty="0">
-                          <a:latin typeface="Calibri" panose="020F0502020204030204" pitchFamily="34" charset="0"/>
-                          <a:cs typeface="Calibri" panose="020F0502020204030204" pitchFamily="34" charset="0"/>
-                        </a:rPr>
-                        <a:t> </a:t>
-                      </a:r>
-                      <a:r>
-                        <a:rPr lang="en-US" altLang="zh-CN" sz="1200" dirty="0">
-                          <a:latin typeface="Calibri" panose="020F0502020204030204" pitchFamily="34" charset="0"/>
-                          <a:ea typeface="Calibri" panose="020F0502020204030204" pitchFamily="34" charset="0"/>
-                          <a:cs typeface="Calibri" panose="020F0502020204030204" pitchFamily="34" charset="0"/>
-                        </a:rPr>
-                        <a:t>- mutations</a:t>
-                      </a:r>
-                      <a:endParaRPr lang="zh-CN" altLang="en-US" sz="1200" dirty="0">
-                        <a:latin typeface="Calibri" panose="020F0502020204030204" pitchFamily="34" charset="0"/>
-                        <a:cs typeface="Calibri" panose="020F0502020204030204" pitchFamily="34" charset="0"/>
-                      </a:endParaRPr>
-                    </a:p>
-                  </a:txBody>
-                  <a:tcPr/>
-                </a:tc>
-                <a:tc>
-                  <a:txBody>
-                    <a:bodyPr/>
-                    <a:lstStyle/>
-                    <a:p>
-                      <a:pPr marL="0" marR="0" lvl="0" indent="0" algn="l" defTabSz="914400" rtl="0" eaLnBrk="1" fontAlgn="auto" latinLnBrk="0" hangingPunct="1">
-                        <a:lnSpc>
-                          <a:spcPct val="100000"/>
-                        </a:lnSpc>
-                        <a:spcBef>
-                          <a:spcPts val="0"/>
-                        </a:spcBef>
-                        <a:spcAft>
-                          <a:spcPts val="0"/>
-                        </a:spcAft>
-                        <a:buClrTx/>
-                        <a:buSzTx/>
-                        <a:buFontTx/>
-                        <a:buNone/>
-                        <a:tabLst/>
-                        <a:defRPr/>
-                      </a:pPr>
-                      <a:r>
-                        <a:rPr lang="en-US" altLang="zh-CN" sz="1200" dirty="0">
-                          <a:latin typeface="Calibri" panose="020F0502020204030204" pitchFamily="34" charset="0"/>
-                          <a:cs typeface="Calibri" panose="020F0502020204030204" pitchFamily="34" charset="0"/>
-                        </a:rPr>
-                        <a:t>our approach - vs</a:t>
-                      </a:r>
-                      <a:endParaRPr lang="zh-CN" altLang="en-US" sz="1200" dirty="0">
-                        <a:latin typeface="Calibri" panose="020F0502020204030204" pitchFamily="34" charset="0"/>
-                        <a:cs typeface="Calibri" panose="020F0502020204030204" pitchFamily="34" charset="0"/>
-                      </a:endParaRPr>
-                    </a:p>
-                  </a:txBody>
-                  <a:tcPr/>
-                </a:tc>
-                <a:extLst>
-                  <a:ext uri="{0D108BD9-81ED-4DB2-BD59-A6C34878D82A}">
-                    <a16:rowId xmlns:a16="http://schemas.microsoft.com/office/drawing/2014/main" val="3466647714"/>
-                  </a:ext>
-                </a:extLst>
-              </a:tr>
-              <a:tr h="277767">
-                <a:tc>
-                  <a:txBody>
-                    <a:bodyPr/>
-                    <a:lstStyle/>
-                    <a:p>
-                      <a:pPr algn="ctr"/>
-                      <a:r>
-                        <a:rPr lang="en-US" altLang="zh-CN" sz="1400" dirty="0">
-                          <a:latin typeface="Arial" panose="020B0604020202020204" pitchFamily="34" charset="0"/>
-                          <a:cs typeface="Arial" panose="020B0604020202020204" pitchFamily="34" charset="0"/>
-                        </a:rPr>
-                        <a:t>gpt-4o</a:t>
-                      </a:r>
-                      <a:endParaRPr lang="zh-CN" altLang="en-US" sz="1400" dirty="0">
-                        <a:latin typeface="Arial" panose="020B0604020202020204" pitchFamily="34" charset="0"/>
-                        <a:cs typeface="Arial" panose="020B0604020202020204" pitchFamily="34" charset="0"/>
-                      </a:endParaRPr>
-                    </a:p>
-                  </a:txBody>
-                  <a:tcPr/>
-                </a:tc>
-                <a:tc>
-                  <a:txBody>
-                    <a:bodyPr/>
-                    <a:lstStyle/>
-                    <a:p>
-                      <a:pPr algn="ctr"/>
-                      <a:r>
-                        <a:rPr lang="en-US" altLang="zh-CN" sz="1400" dirty="0">
-                          <a:latin typeface="Arial" panose="020B0604020202020204" pitchFamily="34" charset="0"/>
-                          <a:cs typeface="Arial" panose="020B0604020202020204" pitchFamily="34" charset="0"/>
-                        </a:rPr>
-                        <a:t>1.4113</a:t>
-                      </a:r>
-                    </a:p>
-                  </a:txBody>
-                  <a:tcPr/>
-                </a:tc>
-                <a:tc>
-                  <a:txBody>
-                    <a:bodyPr/>
-                    <a:lstStyle/>
-                    <a:p>
-                      <a:pPr algn="ctr"/>
-                      <a:r>
-                        <a:rPr lang="en-US" altLang="zh-CN" sz="1400" dirty="0">
-                          <a:latin typeface="Arial" panose="020B0604020202020204" pitchFamily="34" charset="0"/>
-                          <a:cs typeface="Arial" panose="020B0604020202020204" pitchFamily="34" charset="0"/>
-                        </a:rPr>
-                        <a:t>30.0015</a:t>
-                      </a:r>
-                      <a:endParaRPr lang="zh-CN" altLang="en-US" sz="1400" dirty="0">
-                        <a:latin typeface="Arial" panose="020B0604020202020204" pitchFamily="34" charset="0"/>
-                        <a:cs typeface="Arial" panose="020B0604020202020204" pitchFamily="34" charset="0"/>
-                      </a:endParaRPr>
-                    </a:p>
-                  </a:txBody>
-                  <a:tcPr/>
-                </a:tc>
-                <a:tc>
-                  <a:txBody>
-                    <a:bodyPr/>
-                    <a:lstStyle/>
-                    <a:p>
-                      <a:pPr algn="ctr"/>
-                      <a:r>
-                        <a:rPr lang="en-US" altLang="zh-CN" sz="1400" dirty="0">
-                          <a:latin typeface="Arial" panose="020B0604020202020204" pitchFamily="34" charset="0"/>
-                          <a:cs typeface="Arial" panose="020B0604020202020204" pitchFamily="34" charset="0"/>
-                        </a:rPr>
-                        <a:t>35.7001</a:t>
-                      </a:r>
-                      <a:endParaRPr lang="zh-CN" altLang="en-US" sz="1400" dirty="0">
-                        <a:latin typeface="Arial" panose="020B0604020202020204" pitchFamily="34" charset="0"/>
-                        <a:cs typeface="Arial" panose="020B0604020202020204" pitchFamily="34" charset="0"/>
-                      </a:endParaRPr>
-                    </a:p>
-                  </a:txBody>
-                  <a:tcPr/>
-                </a:tc>
-                <a:tc>
-                  <a:txBody>
-                    <a:bodyPr/>
-                    <a:lstStyle/>
-                    <a:p>
-                      <a:pPr algn="ctr"/>
-                      <a:r>
-                        <a:rPr lang="en-US" altLang="zh-CN" sz="1400" dirty="0">
-                          <a:latin typeface="Arial" panose="020B0604020202020204" pitchFamily="34" charset="0"/>
-                          <a:cs typeface="Arial" panose="020B0604020202020204" pitchFamily="34" charset="0"/>
-                        </a:rPr>
-                        <a:t>1.8135</a:t>
-                      </a:r>
-                      <a:endParaRPr lang="zh-CN" altLang="en-US" sz="1400" dirty="0">
-                        <a:latin typeface="Arial" panose="020B0604020202020204" pitchFamily="34" charset="0"/>
-                        <a:cs typeface="Arial" panose="020B0604020202020204" pitchFamily="34" charset="0"/>
-                      </a:endParaRPr>
-                    </a:p>
-                  </a:txBody>
-                  <a:tcPr/>
-                </a:tc>
-                <a:tc>
-                  <a:txBody>
-                    <a:bodyPr/>
-                    <a:lstStyle/>
-                    <a:p>
-                      <a:pPr algn="ctr"/>
-                      <a:r>
-                        <a:rPr lang="en-US" altLang="zh-CN" sz="1400" dirty="0">
-                          <a:latin typeface="Arial" panose="020B0604020202020204" pitchFamily="34" charset="0"/>
-                          <a:cs typeface="Arial" panose="020B0604020202020204" pitchFamily="34" charset="0"/>
-                        </a:rPr>
-                        <a:t>11.2498</a:t>
-                      </a:r>
-                      <a:endParaRPr lang="zh-CN" altLang="en-US" sz="1400" dirty="0">
-                        <a:latin typeface="Arial" panose="020B0604020202020204" pitchFamily="34" charset="0"/>
-                        <a:cs typeface="Arial" panose="020B0604020202020204" pitchFamily="34" charset="0"/>
-                      </a:endParaRPr>
-                    </a:p>
-                  </a:txBody>
-                  <a:tcPr/>
-                </a:tc>
-                <a:tc>
-                  <a:txBody>
-                    <a:bodyPr/>
-                    <a:lstStyle/>
-                    <a:p>
-                      <a:pPr algn="ctr"/>
-                      <a:r>
-                        <a:rPr lang="en-US" altLang="zh-CN" sz="1400" dirty="0">
-                          <a:latin typeface="Arial" panose="020B0604020202020204" pitchFamily="34" charset="0"/>
-                          <a:cs typeface="Arial" panose="020B0604020202020204" pitchFamily="34" charset="0"/>
-                        </a:rPr>
-                        <a:t>4.4483</a:t>
-                      </a:r>
-                      <a:endParaRPr lang="zh-CN" altLang="en-US" sz="1400" dirty="0">
-                        <a:latin typeface="Arial" panose="020B0604020202020204" pitchFamily="34" charset="0"/>
-                        <a:cs typeface="Arial" panose="020B0604020202020204" pitchFamily="34" charset="0"/>
-                      </a:endParaRPr>
-                    </a:p>
-                  </a:txBody>
-                  <a:tcPr/>
-                </a:tc>
-                <a:extLst>
-                  <a:ext uri="{0D108BD9-81ED-4DB2-BD59-A6C34878D82A}">
-                    <a16:rowId xmlns:a16="http://schemas.microsoft.com/office/drawing/2014/main" val="971162633"/>
-                  </a:ext>
-                </a:extLst>
-              </a:tr>
-              <a:tr h="277767">
-                <a:tc>
-                  <a:txBody>
-                    <a:bodyPr/>
-                    <a:lstStyle/>
-                    <a:p>
-                      <a:pPr algn="ctr"/>
-                      <a:r>
-                        <a:rPr lang="en-US" altLang="zh-CN" sz="1400" dirty="0">
-                          <a:latin typeface="Arial" panose="020B0604020202020204" pitchFamily="34" charset="0"/>
-                          <a:cs typeface="Arial" panose="020B0604020202020204" pitchFamily="34" charset="0"/>
-                        </a:rPr>
-                        <a:t>gpt-5</a:t>
-                      </a:r>
-                      <a:endParaRPr lang="zh-CN" altLang="en-US" sz="1400" dirty="0">
-                        <a:latin typeface="Arial" panose="020B0604020202020204" pitchFamily="34" charset="0"/>
-                        <a:cs typeface="Arial" panose="020B0604020202020204" pitchFamily="34" charset="0"/>
-                      </a:endParaRPr>
-                    </a:p>
-                  </a:txBody>
-                  <a:tcPr/>
-                </a:tc>
-                <a:tc>
-                  <a:txBody>
-                    <a:bodyPr/>
-                    <a:lstStyle/>
-                    <a:p>
-                      <a:pPr marL="0" marR="0" lvl="0" indent="0" algn="ctr" defTabSz="914400" rtl="0" eaLnBrk="1" fontAlgn="auto" latinLnBrk="0" hangingPunct="1">
-                        <a:lnSpc>
-                          <a:spcPct val="100000"/>
-                        </a:lnSpc>
-                        <a:spcBef>
-                          <a:spcPts val="0"/>
-                        </a:spcBef>
-                        <a:spcAft>
-                          <a:spcPts val="0"/>
-                        </a:spcAft>
-                        <a:buClrTx/>
-                        <a:buSzTx/>
-                        <a:buFontTx/>
-                        <a:buNone/>
-                        <a:tabLst/>
-                        <a:defRPr/>
-                      </a:pPr>
-                      <a:r>
-                        <a:rPr lang="en-US" altLang="zh-CN" sz="1400" dirty="0">
-                          <a:latin typeface="Arial" panose="020B0604020202020204" pitchFamily="34" charset="0"/>
-                          <a:cs typeface="Arial" panose="020B0604020202020204" pitchFamily="34" charset="0"/>
-                        </a:rPr>
-                        <a:t>12.4434</a:t>
-                      </a:r>
-                      <a:endParaRPr lang="zh-CN" altLang="en-US" sz="1400" dirty="0">
-                        <a:latin typeface="Arial" panose="020B0604020202020204" pitchFamily="34" charset="0"/>
-                        <a:cs typeface="Arial" panose="020B0604020202020204" pitchFamily="34" charset="0"/>
-                      </a:endParaRPr>
-                    </a:p>
-                  </a:txBody>
-                  <a:tcPr/>
-                </a:tc>
-                <a:tc>
-                  <a:txBody>
-                    <a:bodyPr/>
-                    <a:lstStyle/>
-                    <a:p>
-                      <a:pPr algn="ctr"/>
-                      <a:r>
-                        <a:rPr lang="en-US" altLang="zh-CN" sz="1400" dirty="0">
-                          <a:latin typeface="Arial" panose="020B0604020202020204" pitchFamily="34" charset="0"/>
-                          <a:cs typeface="Arial" panose="020B0604020202020204" pitchFamily="34" charset="0"/>
-                        </a:rPr>
-                        <a:t>202.180</a:t>
-                      </a:r>
-                      <a:endParaRPr lang="zh-CN" altLang="en-US" sz="1400" dirty="0">
-                        <a:latin typeface="Arial" panose="020B0604020202020204" pitchFamily="34" charset="0"/>
-                        <a:cs typeface="Arial" panose="020B0604020202020204" pitchFamily="34" charset="0"/>
-                      </a:endParaRPr>
-                    </a:p>
-                  </a:txBody>
-                  <a:tcPr/>
-                </a:tc>
-                <a:tc>
-                  <a:txBody>
-                    <a:bodyPr/>
-                    <a:lstStyle/>
-                    <a:p>
-                      <a:pPr algn="ctr"/>
-                      <a:r>
-                        <a:rPr lang="en-US" altLang="zh-CN" sz="1400" dirty="0">
-                          <a:latin typeface="Arial" panose="020B0604020202020204" pitchFamily="34" charset="0"/>
-                          <a:cs typeface="Arial" panose="020B0604020202020204" pitchFamily="34" charset="0"/>
-                        </a:rPr>
-                        <a:t>142.808</a:t>
-                      </a:r>
-                      <a:endParaRPr lang="zh-CN" altLang="en-US" sz="1400" dirty="0">
-                        <a:latin typeface="Arial" panose="020B0604020202020204" pitchFamily="34" charset="0"/>
-                        <a:cs typeface="Arial" panose="020B0604020202020204" pitchFamily="34" charset="0"/>
-                      </a:endParaRPr>
-                    </a:p>
-                  </a:txBody>
-                  <a:tcPr/>
-                </a:tc>
-                <a:tc>
-                  <a:txBody>
-                    <a:bodyPr/>
-                    <a:lstStyle/>
-                    <a:p>
-                      <a:pPr algn="ctr"/>
-                      <a:r>
-                        <a:rPr lang="en-US" altLang="zh-CN" sz="1400" dirty="0">
-                          <a:latin typeface="Arial" panose="020B0604020202020204" pitchFamily="34" charset="0"/>
-                          <a:cs typeface="Arial" panose="020B0604020202020204" pitchFamily="34" charset="0"/>
-                        </a:rPr>
-                        <a:t>21.4348</a:t>
-                      </a:r>
-                      <a:endParaRPr lang="zh-CN" altLang="en-US" sz="1400" dirty="0">
-                        <a:latin typeface="Arial" panose="020B0604020202020204" pitchFamily="34" charset="0"/>
-                        <a:cs typeface="Arial" panose="020B0604020202020204" pitchFamily="34" charset="0"/>
-                      </a:endParaRPr>
-                    </a:p>
-                  </a:txBody>
-                  <a:tcPr/>
-                </a:tc>
-                <a:tc>
-                  <a:txBody>
-                    <a:bodyPr/>
-                    <a:lstStyle/>
-                    <a:p>
-                      <a:pPr algn="ctr"/>
-                      <a:r>
-                        <a:rPr lang="en-US" altLang="zh-CN" sz="1400" dirty="0">
-                          <a:latin typeface="Arial" panose="020B0604020202020204" pitchFamily="34" charset="0"/>
-                          <a:cs typeface="Arial" panose="020B0604020202020204" pitchFamily="34" charset="0"/>
-                        </a:rPr>
-                        <a:t>187.810</a:t>
-                      </a:r>
-                      <a:endParaRPr lang="zh-CN" altLang="en-US" sz="1400" dirty="0">
-                        <a:latin typeface="Arial" panose="020B0604020202020204" pitchFamily="34" charset="0"/>
-                        <a:cs typeface="Arial" panose="020B0604020202020204" pitchFamily="34" charset="0"/>
-                      </a:endParaRPr>
-                    </a:p>
-                  </a:txBody>
-                  <a:tcPr/>
-                </a:tc>
-                <a:tc>
-                  <a:txBody>
-                    <a:bodyPr/>
-                    <a:lstStyle/>
-                    <a:p>
-                      <a:pPr algn="ctr"/>
-                      <a:r>
-                        <a:rPr lang="en-US" altLang="zh-CN" sz="1400" dirty="0">
-                          <a:latin typeface="Arial" panose="020B0604020202020204" pitchFamily="34" charset="0"/>
-                          <a:cs typeface="Arial" panose="020B0604020202020204" pitchFamily="34" charset="0"/>
-                        </a:rPr>
-                        <a:t>36.9961</a:t>
-                      </a:r>
-                      <a:endParaRPr lang="zh-CN" altLang="en-US" sz="1400" dirty="0">
-                        <a:latin typeface="Arial" panose="020B0604020202020204" pitchFamily="34" charset="0"/>
-                        <a:cs typeface="Arial" panose="020B0604020202020204" pitchFamily="34" charset="0"/>
-                      </a:endParaRPr>
-                    </a:p>
-                  </a:txBody>
-                  <a:tcPr/>
-                </a:tc>
-                <a:extLst>
-                  <a:ext uri="{0D108BD9-81ED-4DB2-BD59-A6C34878D82A}">
-                    <a16:rowId xmlns:a16="http://schemas.microsoft.com/office/drawing/2014/main" val="2166985772"/>
-                  </a:ext>
-                </a:extLst>
-              </a:tr>
-            </a:tbl>
-          </a:graphicData>
-        </a:graphic>
-      </p:graphicFrame>
-      <p:sp>
-        <p:nvSpPr>
-          <p:cNvPr id="11" name="文本框 10">
-            <a:extLst>
-              <a:ext uri="{FF2B5EF4-FFF2-40B4-BE49-F238E27FC236}">
-                <a16:creationId xmlns:a16="http://schemas.microsoft.com/office/drawing/2014/main" id="{C0CCBC1A-83EC-228E-417D-8BB79203B20F}"/>
+      <p:sp>
+        <p:nvSpPr>
+          <p:cNvPr id="4" name="文本框 3">
+            <a:extLst>
+              <a:ext uri="{FF2B5EF4-FFF2-40B4-BE49-F238E27FC236}">
+                <a16:creationId xmlns:a16="http://schemas.microsoft.com/office/drawing/2014/main" id="{73F56270-4478-A98D-9C20-529D9176D4A1}"/>
               </a:ext>
             </a:extLst>
           </p:cNvPr>
@@ -5305,7 +3630,7 @@
         <p:spPr>
           <a:xfrm>
             <a:off x="479719" y="151179"/>
-            <a:ext cx="11219222" cy="584775"/>
+            <a:ext cx="11219222" cy="5693866"/>
           </a:xfrm>
           <a:prstGeom prst="rect">
             <a:avLst/>
@@ -5323,49 +3648,160 @@
                 <a:latin typeface="Arial" panose="020B0604020202020204" pitchFamily="34" charset="0"/>
                 <a:cs typeface="Arial" panose="020B0604020202020204" pitchFamily="34" charset="0"/>
               </a:rPr>
-              <a:t>Experiment evaluation</a:t>
-            </a:r>
+              <a:t>Research Questions:</a:t>
+            </a:r>
+          </a:p>
+          <a:p>
+            <a:endParaRPr lang="en-US" altLang="zh-CN" sz="3200" dirty="0">
+              <a:latin typeface="Arial" panose="020B0604020202020204" pitchFamily="34" charset="0"/>
+              <a:cs typeface="Arial" panose="020B0604020202020204" pitchFamily="34" charset="0"/>
+            </a:endParaRPr>
+          </a:p>
+          <a:p>
+            <a:r>
+              <a:rPr lang="en-US" altLang="zh-CN" sz="2000" dirty="0">
+                <a:latin typeface="Arial" panose="020B0604020202020204" pitchFamily="34" charset="0"/>
+                <a:cs typeface="Arial" panose="020B0604020202020204" pitchFamily="34" charset="0"/>
+              </a:rPr>
+              <a:t>RQ1: overall performance (repair accuracy)</a:t>
+            </a:r>
+          </a:p>
+          <a:p>
+            <a:r>
+              <a:rPr lang="en-US" altLang="zh-CN" sz="2000" dirty="0">
+                <a:latin typeface="Arial" panose="020B0604020202020204" pitchFamily="34" charset="0"/>
+                <a:cs typeface="Arial" panose="020B0604020202020204" pitchFamily="34" charset="0"/>
+              </a:rPr>
+              <a:t>comparison between approaches without external knowledge source (chain of thought, chain of verification, our approach, our approach with mutations)</a:t>
+            </a:r>
+          </a:p>
+          <a:p>
+            <a:r>
+              <a:rPr lang="en-US" altLang="zh-CN" sz="2000" dirty="0">
+                <a:latin typeface="Arial" panose="020B0604020202020204" pitchFamily="34" charset="0"/>
+                <a:cs typeface="Arial" panose="020B0604020202020204" pitchFamily="34" charset="0"/>
+              </a:rPr>
+              <a:t>comparison between approaches with external knowledge source (cove-search engine, RAG, our approach, our approach with mutations)</a:t>
+            </a:r>
+          </a:p>
+          <a:p>
+            <a:r>
+              <a:rPr lang="en-US" altLang="zh-CN" sz="2000" dirty="0">
+                <a:solidFill>
+                  <a:srgbClr val="FF0000"/>
+                </a:solidFill>
+                <a:latin typeface="Arial" panose="020B0604020202020204" pitchFamily="34" charset="0"/>
+                <a:cs typeface="Arial" panose="020B0604020202020204" pitchFamily="34" charset="0"/>
+              </a:rPr>
+              <a:t>how to compare with RAG?</a:t>
+            </a:r>
+          </a:p>
+          <a:p>
             <a:endParaRPr lang="en-US" altLang="zh-CN" sz="2000" dirty="0">
               <a:latin typeface="Arial" panose="020B0604020202020204" pitchFamily="34" charset="0"/>
               <a:cs typeface="Arial" panose="020B0604020202020204" pitchFamily="34" charset="0"/>
             </a:endParaRPr>
           </a:p>
-        </p:txBody>
-      </p:sp>
-      <p:pic>
-        <p:nvPicPr>
-          <p:cNvPr id="3" name="图片 2" descr="图表, 条形图&#10;&#10;AI 生成的内容可能不正确。">
-            <a:extLst>
-              <a:ext uri="{FF2B5EF4-FFF2-40B4-BE49-F238E27FC236}">
-                <a16:creationId xmlns:a16="http://schemas.microsoft.com/office/drawing/2014/main" id="{E0732084-029F-0C9E-16EA-D9609DBC290E}"/>
-              </a:ext>
-            </a:extLst>
-          </p:cNvPr>
-          <p:cNvPicPr>
-            <a:picLocks noChangeAspect="1"/>
-          </p:cNvPicPr>
-          <p:nvPr/>
-        </p:nvPicPr>
-        <p:blipFill>
-          <a:blip r:embed="rId2"/>
-          <a:stretch>
-            <a:fillRect/>
-          </a:stretch>
-        </p:blipFill>
-        <p:spPr>
-          <a:xfrm>
-            <a:off x="493059" y="735954"/>
-            <a:ext cx="4785360" cy="5189220"/>
-          </a:xfrm>
-          <a:prstGeom prst="rect">
-            <a:avLst/>
-          </a:prstGeom>
-        </p:spPr>
-      </p:pic>
+          <a:p>
+            <a:r>
+              <a:rPr lang="en-US" altLang="zh-CN" sz="2000" dirty="0">
+                <a:latin typeface="Arial" panose="020B0604020202020204" pitchFamily="34" charset="0"/>
+                <a:cs typeface="Arial" panose="020B0604020202020204" pitchFamily="34" charset="0"/>
+              </a:rPr>
+              <a:t>RQ2: overcorrection</a:t>
+            </a:r>
+          </a:p>
+          <a:p>
+            <a:endParaRPr lang="en-US" altLang="zh-CN" sz="2000" dirty="0">
+              <a:latin typeface="Arial" panose="020B0604020202020204" pitchFamily="34" charset="0"/>
+              <a:cs typeface="Arial" panose="020B0604020202020204" pitchFamily="34" charset="0"/>
+            </a:endParaRPr>
+          </a:p>
+          <a:p>
+            <a:r>
+              <a:rPr lang="en-US" altLang="zh-CN" sz="2000" dirty="0">
+                <a:latin typeface="Arial" panose="020B0604020202020204" pitchFamily="34" charset="0"/>
+                <a:cs typeface="Arial" panose="020B0604020202020204" pitchFamily="34" charset="0"/>
+              </a:rPr>
+              <a:t>RQ3: stability</a:t>
+            </a:r>
+          </a:p>
+          <a:p>
+            <a:endParaRPr lang="en-US" altLang="zh-CN" sz="2000" dirty="0">
+              <a:latin typeface="Arial" panose="020B0604020202020204" pitchFamily="34" charset="0"/>
+              <a:cs typeface="Arial" panose="020B0604020202020204" pitchFamily="34" charset="0"/>
+            </a:endParaRPr>
+          </a:p>
+          <a:p>
+            <a:r>
+              <a:rPr lang="en-US" altLang="zh-CN" sz="2000" dirty="0">
+                <a:latin typeface="Arial" panose="020B0604020202020204" pitchFamily="34" charset="0"/>
+                <a:cs typeface="Arial" panose="020B0604020202020204" pitchFamily="34" charset="0"/>
+              </a:rPr>
+              <a:t>RQ4: ablations</a:t>
+            </a:r>
+          </a:p>
+          <a:p>
+            <a:r>
+              <a:rPr lang="en-US" altLang="zh-CN" sz="2000" dirty="0">
+                <a:latin typeface="Arial" panose="020B0604020202020204" pitchFamily="34" charset="0"/>
+                <a:cs typeface="Arial" panose="020B0604020202020204" pitchFamily="34" charset="0"/>
+              </a:rPr>
+              <a:t>number of mutations:</a:t>
+            </a:r>
+          </a:p>
+          <a:p>
+            <a:r>
+              <a:rPr lang="en-US" altLang="zh-CN" sz="2000" dirty="0">
+                <a:latin typeface="Arial" panose="020B0604020202020204" pitchFamily="34" charset="0"/>
+                <a:cs typeface="Arial" panose="020B0604020202020204" pitchFamily="34" charset="0"/>
+              </a:rPr>
+              <a:t>temperature in (mutation generation, </a:t>
+            </a:r>
+            <a:r>
+              <a:rPr lang="en-US" altLang="zh-CN" sz="2000" dirty="0" err="1">
+                <a:latin typeface="Arial" panose="020B0604020202020204" pitchFamily="34" charset="0"/>
+                <a:cs typeface="Arial" panose="020B0604020202020204" pitchFamily="34" charset="0"/>
+              </a:rPr>
+              <a:t>llm</a:t>
+            </a:r>
+            <a:r>
+              <a:rPr lang="en-US" altLang="zh-CN" sz="2000" dirty="0">
+                <a:latin typeface="Arial" panose="020B0604020202020204" pitchFamily="34" charset="0"/>
+                <a:cs typeface="Arial" panose="020B0604020202020204" pitchFamily="34" charset="0"/>
+              </a:rPr>
+              <a:t>-as-judge)</a:t>
+            </a:r>
+          </a:p>
+          <a:p>
+            <a:r>
+              <a:rPr lang="en-US" altLang="zh-CN" sz="2000" dirty="0">
+                <a:latin typeface="Arial" panose="020B0604020202020204" pitchFamily="34" charset="0"/>
+                <a:cs typeface="Arial" panose="020B0604020202020204" pitchFamily="34" charset="0"/>
+              </a:rPr>
+              <a:t>inner comparison in </a:t>
+            </a:r>
+            <a:r>
+              <a:rPr lang="en-US" altLang="zh-CN" sz="2000" dirty="0" err="1">
+                <a:latin typeface="Arial" panose="020B0604020202020204" pitchFamily="34" charset="0"/>
+                <a:cs typeface="Arial" panose="020B0604020202020204" pitchFamily="34" charset="0"/>
+              </a:rPr>
+              <a:t>llm</a:t>
+            </a:r>
+            <a:r>
+              <a:rPr lang="en-US" altLang="zh-CN" sz="2000" dirty="0">
+                <a:latin typeface="Arial" panose="020B0604020202020204" pitchFamily="34" charset="0"/>
+                <a:cs typeface="Arial" panose="020B0604020202020204" pitchFamily="34" charset="0"/>
+              </a:rPr>
+              <a:t>-as-judge (majority voting, confidence score, ranking)</a:t>
+            </a:r>
+          </a:p>
+        </p:txBody>
+      </p:sp>
     </p:spTree>
     <p:extLst>
       <p:ext uri="{BB962C8B-B14F-4D97-AF65-F5344CB8AC3E}">
-        <p14:creationId xmlns:p14="http://schemas.microsoft.com/office/powerpoint/2010/main" val="495306369"/>
+        <p14:creationId xmlns:p14="http://schemas.microsoft.com/office/powerpoint/2010/main" val="547329232"/>
       </p:ext>
     </p:extLst>
   </p:cSld>

</xml_diff>

<commit_message>
update code and slides
</commit_message>
<xml_diff>
--- a/slides/20260108.pptx
+++ b/slides/20260108.pptx
@@ -3490,7 +3490,14 @@
                 <a:latin typeface="Arial" panose="020B0604020202020204" pitchFamily="34" charset="0"/>
                 <a:cs typeface="Arial" panose="020B0604020202020204" pitchFamily="34" charset="0"/>
               </a:rPr>
-              <a:t>close-source models: gpt-4o, gpt-5, gemini-3-pro-preview-11-2025</a:t>
+              <a:t>close-source models: gpt-4o, gpt-5</a:t>
+            </a:r>
+            <a:r>
+              <a:rPr lang="en-US" altLang="zh-CN" sz="2000">
+                <a:latin typeface="Arial" panose="020B0604020202020204" pitchFamily="34" charset="0"/>
+                <a:cs typeface="Arial" panose="020B0604020202020204" pitchFamily="34" charset="0"/>
+              </a:rPr>
+              <a:t>, gemini-2.5-flash-thinking</a:t>
             </a:r>
           </a:p>
           <a:p>

</xml_diff>